<commit_message>
Improved figures in Chapter 5
</commit_message>
<xml_diff>
--- a/chapter_05/figures/break_down_scores.pptx
+++ b/chapter_05/figures/break_down_scores.pptx
@@ -125,1560 +125,16 @@
   <pc:docChgLst>
     <pc:chgData name="Fatima Pillosu" userId="a6295d4dc9e22643" providerId="LiveId" clId="{87453732-75AC-4426-B5D3-B7C69C2D4F54}"/>
     <pc:docChg chg="undo custSel modSld">
-      <pc:chgData name="Fatima Pillosu" userId="a6295d4dc9e22643" providerId="LiveId" clId="{87453732-75AC-4426-B5D3-B7C69C2D4F54}" dt="2026-01-23T06:35:33.051" v="1470"/>
+      <pc:chgData name="Fatima Pillosu" userId="a6295d4dc9e22643" providerId="LiveId" clId="{87453732-75AC-4426-B5D3-B7C69C2D4F54}" dt="2026-01-26T16:16:25.010" v="1472" actId="478"/>
       <pc:docMkLst>
         <pc:docMk/>
       </pc:docMkLst>
       <pc:sldChg chg="addSp delSp modSp mod">
-        <pc:chgData name="Fatima Pillosu" userId="a6295d4dc9e22643" providerId="LiveId" clId="{87453732-75AC-4426-B5D3-B7C69C2D4F54}" dt="2026-01-23T06:35:33.051" v="1470"/>
+        <pc:chgData name="Fatima Pillosu" userId="a6295d4dc9e22643" providerId="LiveId" clId="{87453732-75AC-4426-B5D3-B7C69C2D4F54}" dt="2026-01-26T16:16:25.010" v="1472" actId="478"/>
         <pc:sldMkLst>
           <pc:docMk/>
           <pc:sldMk cId="1573992039" sldId="256"/>
         </pc:sldMkLst>
-        <pc:spChg chg="add mod">
-          <ac:chgData name="Fatima Pillosu" userId="a6295d4dc9e22643" providerId="LiveId" clId="{87453732-75AC-4426-B5D3-B7C69C2D4F54}" dt="2026-01-23T06:16:04.064" v="772" actId="1037"/>
-          <ac:spMkLst>
-            <pc:docMk/>
-            <pc:sldMk cId="1573992039" sldId="256"/>
-            <ac:spMk id="2" creationId="{14E6CDA0-E2DD-16E6-5071-4F39FB099BBE}"/>
-          </ac:spMkLst>
-        </pc:spChg>
-        <pc:spChg chg="add del mod">
-          <ac:chgData name="Fatima Pillosu" userId="a6295d4dc9e22643" providerId="LiveId" clId="{87453732-75AC-4426-B5D3-B7C69C2D4F54}" dt="2026-01-23T06:13:48.032" v="647" actId="478"/>
-          <ac:spMkLst>
-            <pc:docMk/>
-            <pc:sldMk cId="1573992039" sldId="256"/>
-            <ac:spMk id="3" creationId="{F582E251-43C2-817C-58C5-0DEFF919A47B}"/>
-          </ac:spMkLst>
-        </pc:spChg>
-        <pc:spChg chg="add mod">
-          <ac:chgData name="Fatima Pillosu" userId="a6295d4dc9e22643" providerId="LiveId" clId="{87453732-75AC-4426-B5D3-B7C69C2D4F54}" dt="2026-01-23T06:21:53.395" v="988" actId="1037"/>
-          <ac:spMkLst>
-            <pc:docMk/>
-            <pc:sldMk cId="1573992039" sldId="256"/>
-            <ac:spMk id="4" creationId="{3A126B8F-AFBD-720A-8ECD-093553E1F30D}"/>
-          </ac:spMkLst>
-        </pc:spChg>
-        <pc:spChg chg="add del mod">
-          <ac:chgData name="Fatima Pillosu" userId="a6295d4dc9e22643" providerId="LiveId" clId="{87453732-75AC-4426-B5D3-B7C69C2D4F54}" dt="2026-01-23T06:20:49.618" v="892" actId="478"/>
-          <ac:spMkLst>
-            <pc:docMk/>
-            <pc:sldMk cId="1573992039" sldId="256"/>
-            <ac:spMk id="5" creationId="{CE838FA8-7ACE-21C7-96B0-E77BFF68ED16}"/>
-          </ac:spMkLst>
-        </pc:spChg>
-        <pc:spChg chg="add mod">
-          <ac:chgData name="Fatima Pillosu" userId="a6295d4dc9e22643" providerId="LiveId" clId="{87453732-75AC-4426-B5D3-B7C69C2D4F54}" dt="2026-01-23T06:10:28.342" v="557"/>
-          <ac:spMkLst>
-            <pc:docMk/>
-            <pc:sldMk cId="1573992039" sldId="256"/>
-            <ac:spMk id="7" creationId="{18B28D34-B240-2EFB-A817-FD53CA305FC9}"/>
-          </ac:spMkLst>
-        </pc:spChg>
-        <pc:spChg chg="add mod">
-          <ac:chgData name="Fatima Pillosu" userId="a6295d4dc9e22643" providerId="LiveId" clId="{87453732-75AC-4426-B5D3-B7C69C2D4F54}" dt="2026-01-23T06:10:39.073" v="560" actId="1076"/>
-          <ac:spMkLst>
-            <pc:docMk/>
-            <pc:sldMk cId="1573992039" sldId="256"/>
-            <ac:spMk id="9" creationId="{12BAFF30-E9BA-AA09-D16E-68AF7C33B467}"/>
-          </ac:spMkLst>
-        </pc:spChg>
-        <pc:spChg chg="add del mod">
-          <ac:chgData name="Fatima Pillosu" userId="a6295d4dc9e22643" providerId="LiveId" clId="{87453732-75AC-4426-B5D3-B7C69C2D4F54}" dt="2026-01-23T06:11:02.574" v="567" actId="478"/>
-          <ac:spMkLst>
-            <pc:docMk/>
-            <pc:sldMk cId="1573992039" sldId="256"/>
-            <ac:spMk id="12" creationId="{E010A639-295C-B4CD-2AC4-192D2DCEAC12}"/>
-          </ac:spMkLst>
-        </pc:spChg>
-        <pc:spChg chg="add mod">
-          <ac:chgData name="Fatima Pillosu" userId="a6295d4dc9e22643" providerId="LiveId" clId="{87453732-75AC-4426-B5D3-B7C69C2D4F54}" dt="2026-01-23T06:11:41.596" v="573" actId="571"/>
-          <ac:spMkLst>
-            <pc:docMk/>
-            <pc:sldMk cId="1573992039" sldId="256"/>
-            <ac:spMk id="15" creationId="{B453D542-26A1-2385-BC4A-5AD59BC8EFA4}"/>
-          </ac:spMkLst>
-        </pc:spChg>
-        <pc:spChg chg="add del mod">
-          <ac:chgData name="Fatima Pillosu" userId="a6295d4dc9e22643" providerId="LiveId" clId="{87453732-75AC-4426-B5D3-B7C69C2D4F54}" dt="2026-01-23T06:12:02.985" v="576" actId="478"/>
-          <ac:spMkLst>
-            <pc:docMk/>
-            <pc:sldMk cId="1573992039" sldId="256"/>
-            <ac:spMk id="19" creationId="{4E4C490A-EE8D-C75F-3332-70926C607B75}"/>
-          </ac:spMkLst>
-        </pc:spChg>
-        <pc:spChg chg="add del mod">
-          <ac:chgData name="Fatima Pillosu" userId="a6295d4dc9e22643" providerId="LiveId" clId="{87453732-75AC-4426-B5D3-B7C69C2D4F54}" dt="2026-01-23T06:12:05.371" v="577" actId="478"/>
-          <ac:spMkLst>
-            <pc:docMk/>
-            <pc:sldMk cId="1573992039" sldId="256"/>
-            <ac:spMk id="21" creationId="{8F67A442-A914-6423-7BA6-0490C4087B32}"/>
-          </ac:spMkLst>
-        </pc:spChg>
-        <pc:spChg chg="add mod">
-          <ac:chgData name="Fatima Pillosu" userId="a6295d4dc9e22643" providerId="LiveId" clId="{87453732-75AC-4426-B5D3-B7C69C2D4F54}" dt="2026-01-23T06:16:17.192" v="783" actId="1038"/>
-          <ac:spMkLst>
-            <pc:docMk/>
-            <pc:sldMk cId="1573992039" sldId="256"/>
-            <ac:spMk id="23" creationId="{96C5C56D-D539-75ED-A571-173D428069D8}"/>
-          </ac:spMkLst>
-        </pc:spChg>
-        <pc:spChg chg="add mod">
-          <ac:chgData name="Fatima Pillosu" userId="a6295d4dc9e22643" providerId="LiveId" clId="{87453732-75AC-4426-B5D3-B7C69C2D4F54}" dt="2026-01-23T06:21:05.469" v="927" actId="1037"/>
-          <ac:spMkLst>
-            <pc:docMk/>
-            <pc:sldMk cId="1573992039" sldId="256"/>
-            <ac:spMk id="24" creationId="{EA0F043E-0C2E-6D6D-32F4-618D960D3F46}"/>
-          </ac:spMkLst>
-        </pc:spChg>
-        <pc:spChg chg="add del mod">
-          <ac:chgData name="Fatima Pillosu" userId="a6295d4dc9e22643" providerId="LiveId" clId="{87453732-75AC-4426-B5D3-B7C69C2D4F54}" dt="2026-01-23T06:22:09.035" v="1010" actId="21"/>
-          <ac:spMkLst>
-            <pc:docMk/>
-            <pc:sldMk cId="1573992039" sldId="256"/>
-            <ac:spMk id="25" creationId="{A59568F9-9015-75D9-1320-AABA6E77C2CC}"/>
-          </ac:spMkLst>
-        </pc:spChg>
-        <pc:spChg chg="add mod">
-          <ac:chgData name="Fatima Pillosu" userId="a6295d4dc9e22643" providerId="LiveId" clId="{87453732-75AC-4426-B5D3-B7C69C2D4F54}" dt="2026-01-23T06:21:05.469" v="927" actId="1037"/>
-          <ac:spMkLst>
-            <pc:docMk/>
-            <pc:sldMk cId="1573992039" sldId="256"/>
-            <ac:spMk id="26" creationId="{0338DE7E-1351-4E77-57B2-D8826AD14EB6}"/>
-          </ac:spMkLst>
-        </pc:spChg>
-        <pc:spChg chg="add mod">
-          <ac:chgData name="Fatima Pillosu" userId="a6295d4dc9e22643" providerId="LiveId" clId="{87453732-75AC-4426-B5D3-B7C69C2D4F54}" dt="2026-01-23T06:21:05.469" v="927" actId="1037"/>
-          <ac:spMkLst>
-            <pc:docMk/>
-            <pc:sldMk cId="1573992039" sldId="256"/>
-            <ac:spMk id="27" creationId="{81C47BA2-1A51-B253-C468-C7E0958B0F23}"/>
-          </ac:spMkLst>
-        </pc:spChg>
-        <pc:spChg chg="add mod">
-          <ac:chgData name="Fatima Pillosu" userId="a6295d4dc9e22643" providerId="LiveId" clId="{87453732-75AC-4426-B5D3-B7C69C2D4F54}" dt="2026-01-23T06:21:05.469" v="927" actId="1037"/>
-          <ac:spMkLst>
-            <pc:docMk/>
-            <pc:sldMk cId="1573992039" sldId="256"/>
-            <ac:spMk id="28" creationId="{8C47F34F-C2B9-4D22-CB2F-416AC0DC9A6A}"/>
-          </ac:spMkLst>
-        </pc:spChg>
-        <pc:spChg chg="add del mod">
-          <ac:chgData name="Fatima Pillosu" userId="a6295d4dc9e22643" providerId="LiveId" clId="{87453732-75AC-4426-B5D3-B7C69C2D4F54}" dt="2026-01-23T06:22:09.035" v="1010" actId="21"/>
-          <ac:spMkLst>
-            <pc:docMk/>
-            <pc:sldMk cId="1573992039" sldId="256"/>
-            <ac:spMk id="29" creationId="{127CFB41-2894-69E3-E62C-3DA0B561D707}"/>
-          </ac:spMkLst>
-        </pc:spChg>
-        <pc:spChg chg="add mod">
-          <ac:chgData name="Fatima Pillosu" userId="a6295d4dc9e22643" providerId="LiveId" clId="{87453732-75AC-4426-B5D3-B7C69C2D4F54}" dt="2026-01-23T06:16:17.192" v="783" actId="1038"/>
-          <ac:spMkLst>
-            <pc:docMk/>
-            <pc:sldMk cId="1573992039" sldId="256"/>
-            <ac:spMk id="30" creationId="{DE46ACD6-2F6A-14B5-B955-0C7AEA9CEDF2}"/>
-          </ac:spMkLst>
-        </pc:spChg>
-        <pc:spChg chg="add del mod">
-          <ac:chgData name="Fatima Pillosu" userId="a6295d4dc9e22643" providerId="LiveId" clId="{87453732-75AC-4426-B5D3-B7C69C2D4F54}" dt="2026-01-23T06:20:47.756" v="891" actId="478"/>
-          <ac:spMkLst>
-            <pc:docMk/>
-            <pc:sldMk cId="1573992039" sldId="256"/>
-            <ac:spMk id="31" creationId="{0A5C0980-00E1-3ED2-0939-8BC348E136AA}"/>
-          </ac:spMkLst>
-        </pc:spChg>
-        <pc:spChg chg="add mod topLvl">
-          <ac:chgData name="Fatima Pillosu" userId="a6295d4dc9e22643" providerId="LiveId" clId="{87453732-75AC-4426-B5D3-B7C69C2D4F54}" dt="2026-01-23T06:16:17.192" v="783" actId="1038"/>
-          <ac:spMkLst>
-            <pc:docMk/>
-            <pc:sldMk cId="1573992039" sldId="256"/>
-            <ac:spMk id="35" creationId="{5B4F7B26-B4B5-0D40-3F80-6AA916B5DA57}"/>
-          </ac:spMkLst>
-        </pc:spChg>
-        <pc:spChg chg="add mod topLvl">
-          <ac:chgData name="Fatima Pillosu" userId="a6295d4dc9e22643" providerId="LiveId" clId="{87453732-75AC-4426-B5D3-B7C69C2D4F54}" dt="2026-01-23T06:16:04.064" v="772" actId="1037"/>
-          <ac:spMkLst>
-            <pc:docMk/>
-            <pc:sldMk cId="1573992039" sldId="256"/>
-            <ac:spMk id="36" creationId="{AE0EE9CA-2952-95D7-1AE5-92C787C56054}"/>
-          </ac:spMkLst>
-        </pc:spChg>
-        <pc:spChg chg="add mod">
-          <ac:chgData name="Fatima Pillosu" userId="a6295d4dc9e22643" providerId="LiveId" clId="{87453732-75AC-4426-B5D3-B7C69C2D4F54}" dt="2026-01-23T06:21:53.395" v="988" actId="1037"/>
-          <ac:spMkLst>
-            <pc:docMk/>
-            <pc:sldMk cId="1573992039" sldId="256"/>
-            <ac:spMk id="38" creationId="{3297B2BF-4D0D-556B-F45A-94CC1A723CB9}"/>
-          </ac:spMkLst>
-        </pc:spChg>
-        <pc:spChg chg="add mod">
-          <ac:chgData name="Fatima Pillosu" userId="a6295d4dc9e22643" providerId="LiveId" clId="{87453732-75AC-4426-B5D3-B7C69C2D4F54}" dt="2026-01-23T06:21:59.559" v="1009" actId="1038"/>
-          <ac:spMkLst>
-            <pc:docMk/>
-            <pc:sldMk cId="1573992039" sldId="256"/>
-            <ac:spMk id="39" creationId="{77199053-8104-C340-2C4F-13E9BDD27CE3}"/>
-          </ac:spMkLst>
-        </pc:spChg>
-        <pc:spChg chg="add mod">
-          <ac:chgData name="Fatima Pillosu" userId="a6295d4dc9e22643" providerId="LiveId" clId="{87453732-75AC-4426-B5D3-B7C69C2D4F54}" dt="2026-01-23T06:21:59.559" v="1009" actId="1038"/>
-          <ac:spMkLst>
-            <pc:docMk/>
-            <pc:sldMk cId="1573992039" sldId="256"/>
-            <ac:spMk id="40" creationId="{1F25A8E1-DFAF-60BA-D80D-D8E2C3BB575B}"/>
-          </ac:spMkLst>
-        </pc:spChg>
-        <pc:spChg chg="add del mod">
-          <ac:chgData name="Fatima Pillosu" userId="a6295d4dc9e22643" providerId="LiveId" clId="{87453732-75AC-4426-B5D3-B7C69C2D4F54}" dt="2026-01-23T06:22:09.035" v="1010" actId="21"/>
-          <ac:spMkLst>
-            <pc:docMk/>
-            <pc:sldMk cId="1573992039" sldId="256"/>
-            <ac:spMk id="41" creationId="{C0C8A410-149F-158E-F679-91E427D63816}"/>
-          </ac:spMkLst>
-        </pc:spChg>
-        <pc:spChg chg="add del mod">
-          <ac:chgData name="Fatima Pillosu" userId="a6295d4dc9e22643" providerId="LiveId" clId="{87453732-75AC-4426-B5D3-B7C69C2D4F54}" dt="2026-01-23T06:22:09.035" v="1010" actId="21"/>
-          <ac:spMkLst>
-            <pc:docMk/>
-            <pc:sldMk cId="1573992039" sldId="256"/>
-            <ac:spMk id="42" creationId="{36CB0B3D-3540-201D-8138-FE2798706A73}"/>
-          </ac:spMkLst>
-        </pc:spChg>
-        <pc:spChg chg="add mod">
-          <ac:chgData name="Fatima Pillosu" userId="a6295d4dc9e22643" providerId="LiveId" clId="{87453732-75AC-4426-B5D3-B7C69C2D4F54}" dt="2026-01-23T06:21:49.213" v="972" actId="1076"/>
-          <ac:spMkLst>
-            <pc:docMk/>
-            <pc:sldMk cId="1573992039" sldId="256"/>
-            <ac:spMk id="43" creationId="{22F12C8E-7AEA-9299-8293-62D57C147948}"/>
-          </ac:spMkLst>
-        </pc:spChg>
-        <pc:spChg chg="add mod">
-          <ac:chgData name="Fatima Pillosu" userId="a6295d4dc9e22643" providerId="LiveId" clId="{87453732-75AC-4426-B5D3-B7C69C2D4F54}" dt="2026-01-23T06:21:59.559" v="1009" actId="1038"/>
-          <ac:spMkLst>
-            <pc:docMk/>
-            <pc:sldMk cId="1573992039" sldId="256"/>
-            <ac:spMk id="45" creationId="{77FD4D4A-103B-9EC6-7188-F3B279FBA747}"/>
-          </ac:spMkLst>
-        </pc:spChg>
-        <pc:spChg chg="add mod">
-          <ac:chgData name="Fatima Pillosu" userId="a6295d4dc9e22643" providerId="LiveId" clId="{87453732-75AC-4426-B5D3-B7C69C2D4F54}" dt="2026-01-23T06:21:59.559" v="1009" actId="1038"/>
-          <ac:spMkLst>
-            <pc:docMk/>
-            <pc:sldMk cId="1573992039" sldId="256"/>
-            <ac:spMk id="46" creationId="{C35B2B84-E0BC-6B81-AE20-2806732D8EE3}"/>
-          </ac:spMkLst>
-        </pc:spChg>
-        <pc:spChg chg="add del mod">
-          <ac:chgData name="Fatima Pillosu" userId="a6295d4dc9e22643" providerId="LiveId" clId="{87453732-75AC-4426-B5D3-B7C69C2D4F54}" dt="2026-01-23T06:22:09.035" v="1010" actId="21"/>
-          <ac:spMkLst>
-            <pc:docMk/>
-            <pc:sldMk cId="1573992039" sldId="256"/>
-            <ac:spMk id="47" creationId="{6061FB66-EF2A-32F8-8668-2468A32FD7DB}"/>
-          </ac:spMkLst>
-        </pc:spChg>
-        <pc:spChg chg="add mod">
-          <ac:chgData name="Fatima Pillosu" userId="a6295d4dc9e22643" providerId="LiveId" clId="{87453732-75AC-4426-B5D3-B7C69C2D4F54}" dt="2026-01-23T06:21:59.559" v="1009" actId="1038"/>
-          <ac:spMkLst>
-            <pc:docMk/>
-            <pc:sldMk cId="1573992039" sldId="256"/>
-            <ac:spMk id="48" creationId="{B6C88C1F-95D1-EBA4-E10A-463652463C74}"/>
-          </ac:spMkLst>
-        </pc:spChg>
-        <pc:spChg chg="add mod">
-          <ac:chgData name="Fatima Pillosu" userId="a6295d4dc9e22643" providerId="LiveId" clId="{87453732-75AC-4426-B5D3-B7C69C2D4F54}" dt="2026-01-23T06:21:59.559" v="1009" actId="1038"/>
-          <ac:spMkLst>
-            <pc:docMk/>
-            <pc:sldMk cId="1573992039" sldId="256"/>
-            <ac:spMk id="49" creationId="{FB87673D-111A-D933-2352-681D2FAD32C0}"/>
-          </ac:spMkLst>
-        </pc:spChg>
-        <pc:spChg chg="del mod">
-          <ac:chgData name="Fatima Pillosu" userId="a6295d4dc9e22643" providerId="LiveId" clId="{87453732-75AC-4426-B5D3-B7C69C2D4F54}" dt="2026-01-23T06:35:24.603" v="1469" actId="21"/>
-          <ac:spMkLst>
-            <pc:docMk/>
-            <pc:sldMk cId="1573992039" sldId="256"/>
-            <ac:spMk id="52" creationId="{1CC68D49-F510-1250-0884-6934B89FDF60}"/>
-          </ac:spMkLst>
-        </pc:spChg>
-        <pc:spChg chg="del">
-          <ac:chgData name="Fatima Pillosu" userId="a6295d4dc9e22643" providerId="LiveId" clId="{87453732-75AC-4426-B5D3-B7C69C2D4F54}" dt="2026-01-23T06:35:24.603" v="1469" actId="21"/>
-          <ac:spMkLst>
-            <pc:docMk/>
-            <pc:sldMk cId="1573992039" sldId="256"/>
-            <ac:spMk id="57" creationId="{D58BBFDB-39D2-B492-5A75-D30A9FDDAEE4}"/>
-          </ac:spMkLst>
-        </pc:spChg>
-        <pc:spChg chg="add mod">
-          <ac:chgData name="Fatima Pillosu" userId="a6295d4dc9e22643" providerId="LiveId" clId="{87453732-75AC-4426-B5D3-B7C69C2D4F54}" dt="2026-01-23T06:22:18.604" v="1011"/>
-          <ac:spMkLst>
-            <pc:docMk/>
-            <pc:sldMk cId="1573992039" sldId="256"/>
-            <ac:spMk id="61" creationId="{964EC952-07EF-AA5F-815E-D6BF5819DB79}"/>
-          </ac:spMkLst>
-        </pc:spChg>
-        <pc:spChg chg="mod">
-          <ac:chgData name="Fatima Pillosu" userId="a6295d4dc9e22643" providerId="LiveId" clId="{87453732-75AC-4426-B5D3-B7C69C2D4F54}" dt="2026-01-23T06:32:17.591" v="1432" actId="1036"/>
-          <ac:spMkLst>
-            <pc:docMk/>
-            <pc:sldMk cId="1573992039" sldId="256"/>
-            <ac:spMk id="63" creationId="{C10D4363-0ACF-905C-8B81-8DD86D3AEA90}"/>
-          </ac:spMkLst>
-        </pc:spChg>
-        <pc:spChg chg="mod">
-          <ac:chgData name="Fatima Pillosu" userId="a6295d4dc9e22643" providerId="LiveId" clId="{87453732-75AC-4426-B5D3-B7C69C2D4F54}" dt="2026-01-23T06:09:21.586" v="389" actId="1076"/>
-          <ac:spMkLst>
-            <pc:docMk/>
-            <pc:sldMk cId="1573992039" sldId="256"/>
-            <ac:spMk id="833" creationId="{C8C3D13A-BFDD-54C1-8A04-DD3BB24773C4}"/>
-          </ac:spMkLst>
-        </pc:spChg>
-        <pc:spChg chg="del">
-          <ac:chgData name="Fatima Pillosu" userId="a6295d4dc9e22643" providerId="LiveId" clId="{87453732-75AC-4426-B5D3-B7C69C2D4F54}" dt="2026-01-23T06:05:53.912" v="146" actId="478"/>
-          <ac:spMkLst>
-            <pc:docMk/>
-            <pc:sldMk cId="1573992039" sldId="256"/>
-            <ac:spMk id="835" creationId="{8DD953F0-D574-7288-6232-DB349985D1C7}"/>
-          </ac:spMkLst>
-        </pc:spChg>
-        <pc:spChg chg="add mod">
-          <ac:chgData name="Fatima Pillosu" userId="a6295d4dc9e22643" providerId="LiveId" clId="{87453732-75AC-4426-B5D3-B7C69C2D4F54}" dt="2026-01-23T06:29:30.682" v="1354" actId="1037"/>
-          <ac:spMkLst>
-            <pc:docMk/>
-            <pc:sldMk cId="1573992039" sldId="256"/>
-            <ac:spMk id="837" creationId="{28602834-4445-244F-EBAA-6A145FEF4FE1}"/>
-          </ac:spMkLst>
-        </pc:spChg>
-        <pc:spChg chg="mod">
-          <ac:chgData name="Fatima Pillosu" userId="a6295d4dc9e22643" providerId="LiveId" clId="{87453732-75AC-4426-B5D3-B7C69C2D4F54}" dt="2026-01-23T06:31:42.437" v="1417" actId="1037"/>
-          <ac:spMkLst>
-            <pc:docMk/>
-            <pc:sldMk cId="1573992039" sldId="256"/>
-            <ac:spMk id="838" creationId="{C401F5C3-E8F7-BAB8-A8F7-724890C219C7}"/>
-          </ac:spMkLst>
-        </pc:spChg>
-        <pc:spChg chg="del">
-          <ac:chgData name="Fatima Pillosu" userId="a6295d4dc9e22643" providerId="LiveId" clId="{87453732-75AC-4426-B5D3-B7C69C2D4F54}" dt="2026-01-23T06:05:53.912" v="146" actId="478"/>
-          <ac:spMkLst>
-            <pc:docMk/>
-            <pc:sldMk cId="1573992039" sldId="256"/>
-            <ac:spMk id="839" creationId="{F86498FD-11B7-6E9F-93AC-A2EA1AAF283D}"/>
-          </ac:spMkLst>
-        </pc:spChg>
-        <pc:spChg chg="mod">
-          <ac:chgData name="Fatima Pillosu" userId="a6295d4dc9e22643" providerId="LiveId" clId="{87453732-75AC-4426-B5D3-B7C69C2D4F54}" dt="2026-01-23T06:31:42.437" v="1417" actId="1037"/>
-          <ac:spMkLst>
-            <pc:docMk/>
-            <pc:sldMk cId="1573992039" sldId="256"/>
-            <ac:spMk id="842" creationId="{99F67917-9AC9-8FE9-8BA3-F13C15B3B3CD}"/>
-          </ac:spMkLst>
-        </pc:spChg>
-        <pc:spChg chg="mod">
-          <ac:chgData name="Fatima Pillosu" userId="a6295d4dc9e22643" providerId="LiveId" clId="{87453732-75AC-4426-B5D3-B7C69C2D4F54}" dt="2026-01-23T06:31:42.437" v="1417" actId="1037"/>
-          <ac:spMkLst>
-            <pc:docMk/>
-            <pc:sldMk cId="1573992039" sldId="256"/>
-            <ac:spMk id="843" creationId="{C8C4BEE6-6376-0E74-4150-BF74DE0D27C7}"/>
-          </ac:spMkLst>
-        </pc:spChg>
-        <pc:spChg chg="del">
-          <ac:chgData name="Fatima Pillosu" userId="a6295d4dc9e22643" providerId="LiveId" clId="{87453732-75AC-4426-B5D3-B7C69C2D4F54}" dt="2026-01-23T06:05:53.912" v="146" actId="478"/>
-          <ac:spMkLst>
-            <pc:docMk/>
-            <pc:sldMk cId="1573992039" sldId="256"/>
-            <ac:spMk id="848" creationId="{4BE5230C-F284-DA67-6488-204B230E83EC}"/>
-          </ac:spMkLst>
-        </pc:spChg>
-        <pc:spChg chg="add mod">
-          <ac:chgData name="Fatima Pillosu" userId="a6295d4dc9e22643" providerId="LiveId" clId="{87453732-75AC-4426-B5D3-B7C69C2D4F54}" dt="2026-01-23T06:31:42.437" v="1417" actId="1037"/>
-          <ac:spMkLst>
-            <pc:docMk/>
-            <pc:sldMk cId="1573992039" sldId="256"/>
-            <ac:spMk id="851" creationId="{31C77472-B4C1-1507-81B9-962B732F7D61}"/>
-          </ac:spMkLst>
-        </pc:spChg>
-        <pc:spChg chg="del">
-          <ac:chgData name="Fatima Pillosu" userId="a6295d4dc9e22643" providerId="LiveId" clId="{87453732-75AC-4426-B5D3-B7C69C2D4F54}" dt="2026-01-23T06:05:53.912" v="146" actId="478"/>
-          <ac:spMkLst>
-            <pc:docMk/>
-            <pc:sldMk cId="1573992039" sldId="256"/>
-            <ac:spMk id="853" creationId="{4FD4C487-6A2F-D1A5-8C60-2E89034A0BCF}"/>
-          </ac:spMkLst>
-        </pc:spChg>
-        <pc:spChg chg="mod">
-          <ac:chgData name="Fatima Pillosu" userId="a6295d4dc9e22643" providerId="LiveId" clId="{87453732-75AC-4426-B5D3-B7C69C2D4F54}" dt="2026-01-23T06:31:42.437" v="1417" actId="1037"/>
-          <ac:spMkLst>
-            <pc:docMk/>
-            <pc:sldMk cId="1573992039" sldId="256"/>
-            <ac:spMk id="855" creationId="{38B04327-CBC3-696A-FEE2-E4AA2D314282}"/>
-          </ac:spMkLst>
-        </pc:spChg>
-        <pc:spChg chg="mod">
-          <ac:chgData name="Fatima Pillosu" userId="a6295d4dc9e22643" providerId="LiveId" clId="{87453732-75AC-4426-B5D3-B7C69C2D4F54}" dt="2026-01-23T06:31:42.437" v="1417" actId="1037"/>
-          <ac:spMkLst>
-            <pc:docMk/>
-            <pc:sldMk cId="1573992039" sldId="256"/>
-            <ac:spMk id="856" creationId="{54066B8D-FAB6-E393-A31E-DBD9964AA0F3}"/>
-          </ac:spMkLst>
-        </pc:spChg>
-        <pc:spChg chg="mod">
-          <ac:chgData name="Fatima Pillosu" userId="a6295d4dc9e22643" providerId="LiveId" clId="{87453732-75AC-4426-B5D3-B7C69C2D4F54}" dt="2026-01-23T06:31:42.437" v="1417" actId="1037"/>
-          <ac:spMkLst>
-            <pc:docMk/>
-            <pc:sldMk cId="1573992039" sldId="256"/>
-            <ac:spMk id="857" creationId="{696A8281-B551-088A-C0CF-AD4F0B2FA950}"/>
-          </ac:spMkLst>
-        </pc:spChg>
-        <pc:spChg chg="mod">
-          <ac:chgData name="Fatima Pillosu" userId="a6295d4dc9e22643" providerId="LiveId" clId="{87453732-75AC-4426-B5D3-B7C69C2D4F54}" dt="2026-01-23T06:26:56.447" v="1268" actId="14100"/>
-          <ac:spMkLst>
-            <pc:docMk/>
-            <pc:sldMk cId="1573992039" sldId="256"/>
-            <ac:spMk id="858" creationId="{89AAB22A-494B-5CBA-B74A-3344AA54BD7D}"/>
-          </ac:spMkLst>
-        </pc:spChg>
-        <pc:spChg chg="del">
-          <ac:chgData name="Fatima Pillosu" userId="a6295d4dc9e22643" providerId="LiveId" clId="{87453732-75AC-4426-B5D3-B7C69C2D4F54}" dt="2026-01-23T06:35:24.603" v="1469" actId="21"/>
-          <ac:spMkLst>
-            <pc:docMk/>
-            <pc:sldMk cId="1573992039" sldId="256"/>
-            <ac:spMk id="859" creationId="{181CF5A4-A6E8-DE3E-D312-EF059C34A5F1}"/>
-          </ac:spMkLst>
-        </pc:spChg>
-        <pc:spChg chg="mod">
-          <ac:chgData name="Fatima Pillosu" userId="a6295d4dc9e22643" providerId="LiveId" clId="{87453732-75AC-4426-B5D3-B7C69C2D4F54}" dt="2026-01-23T06:28:55.409" v="1328" actId="1037"/>
-          <ac:spMkLst>
-            <pc:docMk/>
-            <pc:sldMk cId="1573992039" sldId="256"/>
-            <ac:spMk id="860" creationId="{14E6CDA0-E2DD-16E6-5071-4F39FB099BBE}"/>
-          </ac:spMkLst>
-        </pc:spChg>
-        <pc:spChg chg="del mod">
-          <ac:chgData name="Fatima Pillosu" userId="a6295d4dc9e22643" providerId="LiveId" clId="{87453732-75AC-4426-B5D3-B7C69C2D4F54}" dt="2026-01-23T06:35:24.603" v="1469" actId="21"/>
-          <ac:spMkLst>
-            <pc:docMk/>
-            <pc:sldMk cId="1573992039" sldId="256"/>
-            <ac:spMk id="861" creationId="{3A126B8F-AFBD-720A-8ECD-093553E1F30D}"/>
-          </ac:spMkLst>
-        </pc:spChg>
-        <pc:spChg chg="mod">
-          <ac:chgData name="Fatima Pillosu" userId="a6295d4dc9e22643" providerId="LiveId" clId="{87453732-75AC-4426-B5D3-B7C69C2D4F54}" dt="2026-01-23T06:27:02.919" v="1287" actId="1037"/>
-          <ac:spMkLst>
-            <pc:docMk/>
-            <pc:sldMk cId="1573992039" sldId="256"/>
-            <ac:spMk id="865" creationId="{96C5C56D-D539-75ED-A571-173D428069D8}"/>
-          </ac:spMkLst>
-        </pc:spChg>
-        <pc:spChg chg="mod">
-          <ac:chgData name="Fatima Pillosu" userId="a6295d4dc9e22643" providerId="LiveId" clId="{87453732-75AC-4426-B5D3-B7C69C2D4F54}" dt="2026-01-23T06:29:30.682" v="1354" actId="1037"/>
-          <ac:spMkLst>
-            <pc:docMk/>
-            <pc:sldMk cId="1573992039" sldId="256"/>
-            <ac:spMk id="866" creationId="{EA0F043E-0C2E-6D6D-32F4-618D960D3F46}"/>
-          </ac:spMkLst>
-        </pc:spChg>
-        <pc:spChg chg="mod">
-          <ac:chgData name="Fatima Pillosu" userId="a6295d4dc9e22643" providerId="LiveId" clId="{87453732-75AC-4426-B5D3-B7C69C2D4F54}" dt="2026-01-23T06:27:02.919" v="1287" actId="1037"/>
-          <ac:spMkLst>
-            <pc:docMk/>
-            <pc:sldMk cId="1573992039" sldId="256"/>
-            <ac:spMk id="867" creationId="{A59568F9-9015-75D9-1320-AABA6E77C2CC}"/>
-          </ac:spMkLst>
-        </pc:spChg>
-        <pc:spChg chg="mod">
-          <ac:chgData name="Fatima Pillosu" userId="a6295d4dc9e22643" providerId="LiveId" clId="{87453732-75AC-4426-B5D3-B7C69C2D4F54}" dt="2026-01-23T06:29:30.682" v="1354" actId="1037"/>
-          <ac:spMkLst>
-            <pc:docMk/>
-            <pc:sldMk cId="1573992039" sldId="256"/>
-            <ac:spMk id="868" creationId="{0338DE7E-1351-4E77-57B2-D8826AD14EB6}"/>
-          </ac:spMkLst>
-        </pc:spChg>
-        <pc:spChg chg="mod">
-          <ac:chgData name="Fatima Pillosu" userId="a6295d4dc9e22643" providerId="LiveId" clId="{87453732-75AC-4426-B5D3-B7C69C2D4F54}" dt="2026-01-23T06:27:02.919" v="1287" actId="1037"/>
-          <ac:spMkLst>
-            <pc:docMk/>
-            <pc:sldMk cId="1573992039" sldId="256"/>
-            <ac:spMk id="869" creationId="{81C47BA2-1A51-B253-C468-C7E0958B0F23}"/>
-          </ac:spMkLst>
-        </pc:spChg>
-        <pc:spChg chg="mod">
-          <ac:chgData name="Fatima Pillosu" userId="a6295d4dc9e22643" providerId="LiveId" clId="{87453732-75AC-4426-B5D3-B7C69C2D4F54}" dt="2026-01-23T06:27:02.919" v="1287" actId="1037"/>
-          <ac:spMkLst>
-            <pc:docMk/>
-            <pc:sldMk cId="1573992039" sldId="256"/>
-            <ac:spMk id="870" creationId="{8C47F34F-C2B9-4D22-CB2F-416AC0DC9A6A}"/>
-          </ac:spMkLst>
-        </pc:spChg>
-        <pc:spChg chg="mod">
-          <ac:chgData name="Fatima Pillosu" userId="a6295d4dc9e22643" providerId="LiveId" clId="{87453732-75AC-4426-B5D3-B7C69C2D4F54}" dt="2026-01-23T06:29:30.682" v="1354" actId="1037"/>
-          <ac:spMkLst>
-            <pc:docMk/>
-            <pc:sldMk cId="1573992039" sldId="256"/>
-            <ac:spMk id="871" creationId="{127CFB41-2894-69E3-E62C-3DA0B561D707}"/>
-          </ac:spMkLst>
-        </pc:spChg>
-        <pc:spChg chg="mod">
-          <ac:chgData name="Fatima Pillosu" userId="a6295d4dc9e22643" providerId="LiveId" clId="{87453732-75AC-4426-B5D3-B7C69C2D4F54}" dt="2026-01-23T06:29:30.682" v="1354" actId="1037"/>
-          <ac:spMkLst>
-            <pc:docMk/>
-            <pc:sldMk cId="1573992039" sldId="256"/>
-            <ac:spMk id="872" creationId="{DE46ACD6-2F6A-14B5-B955-0C7AEA9CEDF2}"/>
-          </ac:spMkLst>
-        </pc:spChg>
-        <pc:spChg chg="mod">
-          <ac:chgData name="Fatima Pillosu" userId="a6295d4dc9e22643" providerId="LiveId" clId="{87453732-75AC-4426-B5D3-B7C69C2D4F54}" dt="2026-01-23T06:29:38.463" v="1356" actId="14100"/>
-          <ac:spMkLst>
-            <pc:docMk/>
-            <pc:sldMk cId="1573992039" sldId="256"/>
-            <ac:spMk id="876" creationId="{5F81FB1E-F02B-3930-7760-882160F38BA4}"/>
-          </ac:spMkLst>
-        </pc:spChg>
-        <pc:spChg chg="mod">
-          <ac:chgData name="Fatima Pillosu" userId="a6295d4dc9e22643" providerId="LiveId" clId="{87453732-75AC-4426-B5D3-B7C69C2D4F54}" dt="2026-01-23T06:32:02.043" v="1419" actId="2711"/>
-          <ac:spMkLst>
-            <pc:docMk/>
-            <pc:sldMk cId="1573992039" sldId="256"/>
-            <ac:spMk id="877" creationId="{5B4F7B26-B4B5-0D40-3F80-6AA916B5DA57}"/>
-          </ac:spMkLst>
-        </pc:spChg>
-        <pc:spChg chg="mod">
-          <ac:chgData name="Fatima Pillosu" userId="a6295d4dc9e22643" providerId="LiveId" clId="{87453732-75AC-4426-B5D3-B7C69C2D4F54}" dt="2026-01-23T06:32:02.043" v="1419" actId="2711"/>
-          <ac:spMkLst>
-            <pc:docMk/>
-            <pc:sldMk cId="1573992039" sldId="256"/>
-            <ac:spMk id="878" creationId="{AE0EE9CA-2952-95D7-1AE5-92C787C56054}"/>
-          </ac:spMkLst>
-        </pc:spChg>
-        <pc:spChg chg="add mod">
-          <ac:chgData name="Fatima Pillosu" userId="a6295d4dc9e22643" providerId="LiveId" clId="{87453732-75AC-4426-B5D3-B7C69C2D4F54}" dt="2026-01-23T06:31:42.437" v="1417" actId="1037"/>
-          <ac:spMkLst>
-            <pc:docMk/>
-            <pc:sldMk cId="1573992039" sldId="256"/>
-            <ac:spMk id="879" creationId="{3297B2BF-4D0D-556B-F45A-94CC1A723CB9}"/>
-          </ac:spMkLst>
-        </pc:spChg>
-        <pc:spChg chg="mod">
-          <ac:chgData name="Fatima Pillosu" userId="a6295d4dc9e22643" providerId="LiveId" clId="{87453732-75AC-4426-B5D3-B7C69C2D4F54}" dt="2026-01-23T06:25:18.256" v="1148" actId="206"/>
-          <ac:spMkLst>
-            <pc:docMk/>
-            <pc:sldMk cId="1573992039" sldId="256"/>
-            <ac:spMk id="880" creationId="{77199053-8104-C340-2C4F-13E9BDD27CE3}"/>
-          </ac:spMkLst>
-        </pc:spChg>
-        <pc:spChg chg="mod">
-          <ac:chgData name="Fatima Pillosu" userId="a6295d4dc9e22643" providerId="LiveId" clId="{87453732-75AC-4426-B5D3-B7C69C2D4F54}" dt="2026-01-23T06:31:29.242" v="1406" actId="1038"/>
-          <ac:spMkLst>
-            <pc:docMk/>
-            <pc:sldMk cId="1573992039" sldId="256"/>
-            <ac:spMk id="883" creationId="{36CB0B3D-3540-201D-8138-FE2798706A73}"/>
-          </ac:spMkLst>
-        </pc:spChg>
-        <pc:spChg chg="add del mod">
-          <ac:chgData name="Fatima Pillosu" userId="a6295d4dc9e22643" providerId="LiveId" clId="{87453732-75AC-4426-B5D3-B7C69C2D4F54}" dt="2026-01-23T06:35:24.603" v="1469" actId="21"/>
-          <ac:spMkLst>
-            <pc:docMk/>
-            <pc:sldMk cId="1573992039" sldId="256"/>
-            <ac:spMk id="884" creationId="{22F12C8E-7AEA-9299-8293-62D57C147948}"/>
-          </ac:spMkLst>
-        </pc:spChg>
-        <pc:spChg chg="mod">
-          <ac:chgData name="Fatima Pillosu" userId="a6295d4dc9e22643" providerId="LiveId" clId="{87453732-75AC-4426-B5D3-B7C69C2D4F54}" dt="2026-01-23T06:31:29.242" v="1406" actId="1038"/>
-          <ac:spMkLst>
-            <pc:docMk/>
-            <pc:sldMk cId="1573992039" sldId="256"/>
-            <ac:spMk id="886" creationId="{77FD4D4A-103B-9EC6-7188-F3B279FBA747}"/>
-          </ac:spMkLst>
-        </pc:spChg>
-        <pc:spChg chg="mod">
-          <ac:chgData name="Fatima Pillosu" userId="a6295d4dc9e22643" providerId="LiveId" clId="{87453732-75AC-4426-B5D3-B7C69C2D4F54}" dt="2026-01-23T06:31:29.242" v="1406" actId="1038"/>
-          <ac:spMkLst>
-            <pc:docMk/>
-            <pc:sldMk cId="1573992039" sldId="256"/>
-            <ac:spMk id="887" creationId="{C35B2B84-E0BC-6B81-AE20-2806732D8EE3}"/>
-          </ac:spMkLst>
-        </pc:spChg>
-        <pc:spChg chg="mod">
-          <ac:chgData name="Fatima Pillosu" userId="a6295d4dc9e22643" providerId="LiveId" clId="{87453732-75AC-4426-B5D3-B7C69C2D4F54}" dt="2026-01-23T06:31:29.242" v="1406" actId="1038"/>
-          <ac:spMkLst>
-            <pc:docMk/>
-            <pc:sldMk cId="1573992039" sldId="256"/>
-            <ac:spMk id="889" creationId="{B6C88C1F-95D1-EBA4-E10A-463652463C74}"/>
-          </ac:spMkLst>
-        </pc:spChg>
-        <pc:spChg chg="mod">
-          <ac:chgData name="Fatima Pillosu" userId="a6295d4dc9e22643" providerId="LiveId" clId="{87453732-75AC-4426-B5D3-B7C69C2D4F54}" dt="2026-01-23T06:25:04.088" v="1146" actId="14100"/>
-          <ac:spMkLst>
-            <pc:docMk/>
-            <pc:sldMk cId="1573992039" sldId="256"/>
-            <ac:spMk id="890" creationId="{FB87673D-111A-D933-2352-681D2FAD32C0}"/>
-          </ac:spMkLst>
-        </pc:spChg>
-        <pc:spChg chg="add mod">
-          <ac:chgData name="Fatima Pillosu" userId="a6295d4dc9e22643" providerId="LiveId" clId="{87453732-75AC-4426-B5D3-B7C69C2D4F54}" dt="2026-01-23T06:31:37.801" v="1413" actId="1037"/>
-          <ac:spMkLst>
-            <pc:docMk/>
-            <pc:sldMk cId="1573992039" sldId="256"/>
-            <ac:spMk id="891" creationId="{34B384FA-F360-F336-2135-AE0B94D1546B}"/>
-          </ac:spMkLst>
-        </pc:spChg>
-        <pc:spChg chg="add mod">
-          <ac:chgData name="Fatima Pillosu" userId="a6295d4dc9e22643" providerId="LiveId" clId="{87453732-75AC-4426-B5D3-B7C69C2D4F54}" dt="2026-01-23T06:25:47.523" v="1172" actId="1076"/>
-          <ac:spMkLst>
-            <pc:docMk/>
-            <pc:sldMk cId="1573992039" sldId="256"/>
-            <ac:spMk id="892" creationId="{DA691BC4-F4DE-842B-9452-C875275E9F2A}"/>
-          </ac:spMkLst>
-        </pc:spChg>
-        <pc:spChg chg="add mod">
-          <ac:chgData name="Fatima Pillosu" userId="a6295d4dc9e22643" providerId="LiveId" clId="{87453732-75AC-4426-B5D3-B7C69C2D4F54}" dt="2026-01-23T06:31:29.242" v="1406" actId="1038"/>
-          <ac:spMkLst>
-            <pc:docMk/>
-            <pc:sldMk cId="1573992039" sldId="256"/>
-            <ac:spMk id="893" creationId="{FF01B57F-A28F-C349-BCD2-AB0A37D9CD66}"/>
-          </ac:spMkLst>
-        </pc:spChg>
-        <pc:spChg chg="add mod">
-          <ac:chgData name="Fatima Pillosu" userId="a6295d4dc9e22643" providerId="LiveId" clId="{87453732-75AC-4426-B5D3-B7C69C2D4F54}" dt="2026-01-23T06:31:14.993" v="1392" actId="1037"/>
-          <ac:spMkLst>
-            <pc:docMk/>
-            <pc:sldMk cId="1573992039" sldId="256"/>
-            <ac:spMk id="894" creationId="{33D75850-5181-FD82-212F-BBE65A5031B1}"/>
-          </ac:spMkLst>
-        </pc:spChg>
-        <pc:spChg chg="add del mod">
-          <ac:chgData name="Fatima Pillosu" userId="a6295d4dc9e22643" providerId="LiveId" clId="{87453732-75AC-4426-B5D3-B7C69C2D4F54}" dt="2026-01-23T06:29:25.625" v="1341" actId="478"/>
-          <ac:spMkLst>
-            <pc:docMk/>
-            <pc:sldMk cId="1573992039" sldId="256"/>
-            <ac:spMk id="895" creationId="{62B8806F-9D67-7798-F9EC-116FFACF06DC}"/>
-          </ac:spMkLst>
-        </pc:spChg>
-        <pc:spChg chg="mod">
-          <ac:chgData name="Fatima Pillosu" userId="a6295d4dc9e22643" providerId="LiveId" clId="{87453732-75AC-4426-B5D3-B7C69C2D4F54}" dt="2026-01-23T06:32:17.591" v="1432" actId="1036"/>
-          <ac:spMkLst>
-            <pc:docMk/>
-            <pc:sldMk cId="1573992039" sldId="256"/>
-            <ac:spMk id="1024" creationId="{93B456C6-CC24-93CB-C4C5-CED60A17A518}"/>
-          </ac:spMkLst>
-        </pc:spChg>
-        <pc:spChg chg="del">
-          <ac:chgData name="Fatima Pillosu" userId="a6295d4dc9e22643" providerId="LiveId" clId="{87453732-75AC-4426-B5D3-B7C69C2D4F54}" dt="2026-01-23T06:35:24.603" v="1469" actId="21"/>
-          <ac:spMkLst>
-            <pc:docMk/>
-            <pc:sldMk cId="1573992039" sldId="256"/>
-            <ac:spMk id="1025" creationId="{6C660C77-D465-82E3-BFA2-7CB49265F32B}"/>
-          </ac:spMkLst>
-        </pc:spChg>
-        <pc:spChg chg="mod">
-          <ac:chgData name="Fatima Pillosu" userId="a6295d4dc9e22643" providerId="LiveId" clId="{87453732-75AC-4426-B5D3-B7C69C2D4F54}" dt="2026-01-23T06:34:42.194" v="1466" actId="1076"/>
-          <ac:spMkLst>
-            <pc:docMk/>
-            <pc:sldMk cId="1573992039" sldId="256"/>
-            <ac:spMk id="1028" creationId="{3D37103F-47C7-BE7F-806C-5E4BECD03EA9}"/>
-          </ac:spMkLst>
-        </pc:spChg>
-        <pc:spChg chg="add mod">
-          <ac:chgData name="Fatima Pillosu" userId="a6295d4dc9e22643" providerId="LiveId" clId="{87453732-75AC-4426-B5D3-B7C69C2D4F54}" dt="2026-01-23T06:34:42.194" v="1466" actId="1076"/>
-          <ac:spMkLst>
-            <pc:docMk/>
-            <pc:sldMk cId="1573992039" sldId="256"/>
-            <ac:spMk id="1029" creationId="{691E9E90-7DD7-6CD0-11D1-3ED706626DD0}"/>
-          </ac:spMkLst>
-        </pc:spChg>
-        <pc:spChg chg="mod">
-          <ac:chgData name="Fatima Pillosu" userId="a6295d4dc9e22643" providerId="LiveId" clId="{87453732-75AC-4426-B5D3-B7C69C2D4F54}" dt="2026-01-23T06:34:42.194" v="1466" actId="1076"/>
-          <ac:spMkLst>
-            <pc:docMk/>
-            <pc:sldMk cId="1573992039" sldId="256"/>
-            <ac:spMk id="1030" creationId="{DCB1B907-5B6C-8E3C-DD69-3607F5EC5EE4}"/>
-          </ac:spMkLst>
-        </pc:spChg>
-        <pc:spChg chg="mod">
-          <ac:chgData name="Fatima Pillosu" userId="a6295d4dc9e22643" providerId="LiveId" clId="{87453732-75AC-4426-B5D3-B7C69C2D4F54}" dt="2026-01-23T06:34:42.194" v="1466" actId="1076"/>
-          <ac:spMkLst>
-            <pc:docMk/>
-            <pc:sldMk cId="1573992039" sldId="256"/>
-            <ac:spMk id="1031" creationId="{09211612-F072-5BD6-1D9B-15C6F9A838C8}"/>
-          </ac:spMkLst>
-        </pc:spChg>
-        <pc:spChg chg="mod">
-          <ac:chgData name="Fatima Pillosu" userId="a6295d4dc9e22643" providerId="LiveId" clId="{87453732-75AC-4426-B5D3-B7C69C2D4F54}" dt="2026-01-23T06:34:42.194" v="1466" actId="1076"/>
-          <ac:spMkLst>
-            <pc:docMk/>
-            <pc:sldMk cId="1573992039" sldId="256"/>
-            <ac:spMk id="1032" creationId="{609B895C-8C96-00FC-B186-7A3C7A3E9132}"/>
-          </ac:spMkLst>
-        </pc:spChg>
-        <pc:spChg chg="mod">
-          <ac:chgData name="Fatima Pillosu" userId="a6295d4dc9e22643" providerId="LiveId" clId="{87453732-75AC-4426-B5D3-B7C69C2D4F54}" dt="2026-01-23T06:34:42.194" v="1466" actId="1076"/>
-          <ac:spMkLst>
-            <pc:docMk/>
-            <pc:sldMk cId="1573992039" sldId="256"/>
-            <ac:spMk id="1033" creationId="{3BD7B3DC-F3A9-B413-076C-142F462DB31E}"/>
-          </ac:spMkLst>
-        </pc:spChg>
-        <pc:spChg chg="add mod">
-          <ac:chgData name="Fatima Pillosu" userId="a6295d4dc9e22643" providerId="LiveId" clId="{87453732-75AC-4426-B5D3-B7C69C2D4F54}" dt="2026-01-23T06:34:42.194" v="1466" actId="1076"/>
-          <ac:spMkLst>
-            <pc:docMk/>
-            <pc:sldMk cId="1573992039" sldId="256"/>
-            <ac:spMk id="1034" creationId="{8E6B5854-5F10-ED6E-F1FA-25BC5AF5C263}"/>
-          </ac:spMkLst>
-        </pc:spChg>
-        <pc:spChg chg="mod">
-          <ac:chgData name="Fatima Pillosu" userId="a6295d4dc9e22643" providerId="LiveId" clId="{87453732-75AC-4426-B5D3-B7C69C2D4F54}" dt="2026-01-23T06:34:42.194" v="1466" actId="1076"/>
-          <ac:spMkLst>
-            <pc:docMk/>
-            <pc:sldMk cId="1573992039" sldId="256"/>
-            <ac:spMk id="1035" creationId="{C8CCCD2D-0089-69E8-21C0-CB0AD3AEB27C}"/>
-          </ac:spMkLst>
-        </pc:spChg>
-        <pc:spChg chg="mod">
-          <ac:chgData name="Fatima Pillosu" userId="a6295d4dc9e22643" providerId="LiveId" clId="{87453732-75AC-4426-B5D3-B7C69C2D4F54}" dt="2026-01-23T06:34:42.194" v="1466" actId="1076"/>
-          <ac:spMkLst>
-            <pc:docMk/>
-            <pc:sldMk cId="1573992039" sldId="256"/>
-            <ac:spMk id="1036" creationId="{8AA02093-FA6D-5D59-6CA4-1FF853835A7E}"/>
-          </ac:spMkLst>
-        </pc:spChg>
-        <pc:spChg chg="add mod">
-          <ac:chgData name="Fatima Pillosu" userId="a6295d4dc9e22643" providerId="LiveId" clId="{87453732-75AC-4426-B5D3-B7C69C2D4F54}" dt="2026-01-23T06:34:35.046" v="1465" actId="1076"/>
-          <ac:spMkLst>
-            <pc:docMk/>
-            <pc:sldMk cId="1573992039" sldId="256"/>
-            <ac:spMk id="1038" creationId="{0A4F13FF-2DF7-6F0C-A0EF-9C67F39AF8D9}"/>
-          </ac:spMkLst>
-        </pc:spChg>
-        <pc:spChg chg="mod">
-          <ac:chgData name="Fatima Pillosu" userId="a6295d4dc9e22643" providerId="LiveId" clId="{87453732-75AC-4426-B5D3-B7C69C2D4F54}" dt="2026-01-23T06:34:35.046" v="1465" actId="1076"/>
-          <ac:spMkLst>
-            <pc:docMk/>
-            <pc:sldMk cId="1573992039" sldId="256"/>
-            <ac:spMk id="1039" creationId="{8614CC6A-136B-38FE-2788-E0D660940D63}"/>
-          </ac:spMkLst>
-        </pc:spChg>
-        <pc:spChg chg="mod">
-          <ac:chgData name="Fatima Pillosu" userId="a6295d4dc9e22643" providerId="LiveId" clId="{87453732-75AC-4426-B5D3-B7C69C2D4F54}" dt="2026-01-23T06:34:35.046" v="1465" actId="1076"/>
-          <ac:spMkLst>
-            <pc:docMk/>
-            <pc:sldMk cId="1573992039" sldId="256"/>
-            <ac:spMk id="1040" creationId="{11D73049-044A-996F-62DF-A3CA868D106B}"/>
-          </ac:spMkLst>
-        </pc:spChg>
-        <pc:spChg chg="mod">
-          <ac:chgData name="Fatima Pillosu" userId="a6295d4dc9e22643" providerId="LiveId" clId="{87453732-75AC-4426-B5D3-B7C69C2D4F54}" dt="2026-01-23T06:34:35.046" v="1465" actId="1076"/>
-          <ac:spMkLst>
-            <pc:docMk/>
-            <pc:sldMk cId="1573992039" sldId="256"/>
-            <ac:spMk id="1041" creationId="{6C363CBB-B56A-F312-7FA8-51FFC4BAD1BC}"/>
-          </ac:spMkLst>
-        </pc:spChg>
-        <pc:spChg chg="mod">
-          <ac:chgData name="Fatima Pillosu" userId="a6295d4dc9e22643" providerId="LiveId" clId="{87453732-75AC-4426-B5D3-B7C69C2D4F54}" dt="2026-01-23T06:16:44.023" v="820" actId="1038"/>
-          <ac:spMkLst>
-            <pc:docMk/>
-            <pc:sldMk cId="1573992039" sldId="256"/>
-            <ac:spMk id="1046" creationId="{F4E1EB47-FB49-B221-8F40-6FAAC8188E34}"/>
-          </ac:spMkLst>
-        </pc:spChg>
-        <pc:spChg chg="del mod">
-          <ac:chgData name="Fatima Pillosu" userId="a6295d4dc9e22643" providerId="LiveId" clId="{87453732-75AC-4426-B5D3-B7C69C2D4F54}" dt="2026-01-23T06:22:09.035" v="1010" actId="21"/>
-          <ac:spMkLst>
-            <pc:docMk/>
-            <pc:sldMk cId="1573992039" sldId="256"/>
-            <ac:spMk id="1047" creationId="{6398BBB5-C5B7-3FA0-2762-675850631296}"/>
-          </ac:spMkLst>
-        </pc:spChg>
-        <pc:spChg chg="mod">
-          <ac:chgData name="Fatima Pillosu" userId="a6295d4dc9e22643" providerId="LiveId" clId="{87453732-75AC-4426-B5D3-B7C69C2D4F54}" dt="2026-01-23T06:17:32.551" v="848" actId="1036"/>
-          <ac:spMkLst>
-            <pc:docMk/>
-            <pc:sldMk cId="1573992039" sldId="256"/>
-            <ac:spMk id="1049" creationId="{059E6EB5-4540-D3FE-63A3-DC776774CD1C}"/>
-          </ac:spMkLst>
-        </pc:spChg>
-        <pc:spChg chg="add del mod">
-          <ac:chgData name="Fatima Pillosu" userId="a6295d4dc9e22643" providerId="LiveId" clId="{87453732-75AC-4426-B5D3-B7C69C2D4F54}" dt="2026-01-23T06:22:09.035" v="1010" actId="21"/>
-          <ac:spMkLst>
-            <pc:docMk/>
-            <pc:sldMk cId="1573992039" sldId="256"/>
-            <ac:spMk id="1052" creationId="{964EC952-07EF-AA5F-815E-D6BF5819DB79}"/>
-          </ac:spMkLst>
-        </pc:spChg>
-        <pc:spChg chg="mod">
-          <ac:chgData name="Fatima Pillosu" userId="a6295d4dc9e22643" providerId="LiveId" clId="{87453732-75AC-4426-B5D3-B7C69C2D4F54}" dt="2026-01-23T06:17:32.551" v="848" actId="1036"/>
-          <ac:spMkLst>
-            <pc:docMk/>
-            <pc:sldMk cId="1573992039" sldId="256"/>
-            <ac:spMk id="1054" creationId="{C10D4363-0ACF-905C-8B81-8DD86D3AEA90}"/>
-          </ac:spMkLst>
-        </pc:spChg>
-        <pc:spChg chg="mod">
-          <ac:chgData name="Fatima Pillosu" userId="a6295d4dc9e22643" providerId="LiveId" clId="{87453732-75AC-4426-B5D3-B7C69C2D4F54}" dt="2026-01-23T06:15:14.491" v="749" actId="1036"/>
-          <ac:spMkLst>
-            <pc:docMk/>
-            <pc:sldMk cId="1573992039" sldId="256"/>
-            <ac:spMk id="1057" creationId="{623AE8A3-7B4D-1507-5807-46EC67FA9068}"/>
-          </ac:spMkLst>
-        </pc:spChg>
-        <pc:spChg chg="mod">
-          <ac:chgData name="Fatima Pillosu" userId="a6295d4dc9e22643" providerId="LiveId" clId="{87453732-75AC-4426-B5D3-B7C69C2D4F54}" dt="2026-01-23T06:17:32.551" v="848" actId="1036"/>
-          <ac:spMkLst>
-            <pc:docMk/>
-            <pc:sldMk cId="1573992039" sldId="256"/>
-            <ac:spMk id="1059" creationId="{3D37103F-47C7-BE7F-806C-5E4BECD03EA9}"/>
-          </ac:spMkLst>
-        </pc:spChg>
-        <pc:spChg chg="mod">
-          <ac:chgData name="Fatima Pillosu" userId="a6295d4dc9e22643" providerId="LiveId" clId="{87453732-75AC-4426-B5D3-B7C69C2D4F54}" dt="2026-01-23T06:17:32.551" v="848" actId="1036"/>
-          <ac:spMkLst>
-            <pc:docMk/>
-            <pc:sldMk cId="1573992039" sldId="256"/>
-            <ac:spMk id="1060" creationId="{691E9E90-7DD7-6CD0-11D1-3ED706626DD0}"/>
-          </ac:spMkLst>
-        </pc:spChg>
-        <pc:spChg chg="del mod">
-          <ac:chgData name="Fatima Pillosu" userId="a6295d4dc9e22643" providerId="LiveId" clId="{87453732-75AC-4426-B5D3-B7C69C2D4F54}" dt="2026-01-23T06:22:09.035" v="1010" actId="21"/>
-          <ac:spMkLst>
-            <pc:docMk/>
-            <pc:sldMk cId="1573992039" sldId="256"/>
-            <ac:spMk id="1061" creationId="{DCB1B907-5B6C-8E3C-DD69-3607F5EC5EE4}"/>
-          </ac:spMkLst>
-        </pc:spChg>
-        <pc:spChg chg="mod">
-          <ac:chgData name="Fatima Pillosu" userId="a6295d4dc9e22643" providerId="LiveId" clId="{87453732-75AC-4426-B5D3-B7C69C2D4F54}" dt="2026-01-23T06:17:32.551" v="848" actId="1036"/>
-          <ac:spMkLst>
-            <pc:docMk/>
-            <pc:sldMk cId="1573992039" sldId="256"/>
-            <ac:spMk id="1062" creationId="{09211612-F072-5BD6-1D9B-15C6F9A838C8}"/>
-          </ac:spMkLst>
-        </pc:spChg>
-        <pc:spChg chg="mod">
-          <ac:chgData name="Fatima Pillosu" userId="a6295d4dc9e22643" providerId="LiveId" clId="{87453732-75AC-4426-B5D3-B7C69C2D4F54}" dt="2026-01-23T06:17:32.551" v="848" actId="1036"/>
-          <ac:spMkLst>
-            <pc:docMk/>
-            <pc:sldMk cId="1573992039" sldId="256"/>
-            <ac:spMk id="1065" creationId="{8E6B5854-5F10-ED6E-F1FA-25BC5AF5C263}"/>
-          </ac:spMkLst>
-        </pc:spChg>
-        <pc:spChg chg="mod">
-          <ac:chgData name="Fatima Pillosu" userId="a6295d4dc9e22643" providerId="LiveId" clId="{87453732-75AC-4426-B5D3-B7C69C2D4F54}" dt="2026-01-23T06:17:32.551" v="848" actId="1036"/>
-          <ac:spMkLst>
-            <pc:docMk/>
-            <pc:sldMk cId="1573992039" sldId="256"/>
-            <ac:spMk id="1067" creationId="{8AA02093-FA6D-5D59-6CA4-1FF853835A7E}"/>
-          </ac:spMkLst>
-        </pc:spChg>
-        <pc:spChg chg="mod">
-          <ac:chgData name="Fatima Pillosu" userId="a6295d4dc9e22643" providerId="LiveId" clId="{87453732-75AC-4426-B5D3-B7C69C2D4F54}" dt="2026-01-23T06:15:14.491" v="749" actId="1036"/>
-          <ac:spMkLst>
-            <pc:docMk/>
-            <pc:sldMk cId="1573992039" sldId="256"/>
-            <ac:spMk id="1068" creationId="{78EFBCC5-7C3E-9B4A-372C-36A98A9D7290}"/>
-          </ac:spMkLst>
-        </pc:spChg>
-        <pc:spChg chg="del">
-          <ac:chgData name="Fatima Pillosu" userId="a6295d4dc9e22643" providerId="LiveId" clId="{87453732-75AC-4426-B5D3-B7C69C2D4F54}" dt="2026-01-23T06:05:53.912" v="146" actId="478"/>
-          <ac:spMkLst>
-            <pc:docMk/>
-            <pc:sldMk cId="1573992039" sldId="256"/>
-            <ac:spMk id="1090" creationId="{4B572820-B33D-97E7-3F9A-1E53270FD862}"/>
-          </ac:spMkLst>
-        </pc:spChg>
-        <pc:spChg chg="del">
-          <ac:chgData name="Fatima Pillosu" userId="a6295d4dc9e22643" providerId="LiveId" clId="{87453732-75AC-4426-B5D3-B7C69C2D4F54}" dt="2026-01-23T06:05:53.912" v="146" actId="478"/>
-          <ac:spMkLst>
-            <pc:docMk/>
-            <pc:sldMk cId="1573992039" sldId="256"/>
-            <ac:spMk id="1091" creationId="{0559E9B8-ED2A-B7C5-CD99-FCCACB55B247}"/>
-          </ac:spMkLst>
-        </pc:spChg>
-        <pc:spChg chg="del">
-          <ac:chgData name="Fatima Pillosu" userId="a6295d4dc9e22643" providerId="LiveId" clId="{87453732-75AC-4426-B5D3-B7C69C2D4F54}" dt="2026-01-23T06:05:53.912" v="146" actId="478"/>
-          <ac:spMkLst>
-            <pc:docMk/>
-            <pc:sldMk cId="1573992039" sldId="256"/>
-            <ac:spMk id="1094" creationId="{06FE1007-0DAE-599E-2214-69669DEB30C2}"/>
-          </ac:spMkLst>
-        </pc:spChg>
-        <pc:spChg chg="del">
-          <ac:chgData name="Fatima Pillosu" userId="a6295d4dc9e22643" providerId="LiveId" clId="{87453732-75AC-4426-B5D3-B7C69C2D4F54}" dt="2026-01-23T06:05:53.912" v="146" actId="478"/>
-          <ac:spMkLst>
-            <pc:docMk/>
-            <pc:sldMk cId="1573992039" sldId="256"/>
-            <ac:spMk id="1096" creationId="{DC726D64-1E53-9623-8AEB-CDFEBC54B3A2}"/>
-          </ac:spMkLst>
-        </pc:spChg>
-        <pc:spChg chg="del">
-          <ac:chgData name="Fatima Pillosu" userId="a6295d4dc9e22643" providerId="LiveId" clId="{87453732-75AC-4426-B5D3-B7C69C2D4F54}" dt="2026-01-23T06:05:53.912" v="146" actId="478"/>
-          <ac:spMkLst>
-            <pc:docMk/>
-            <pc:sldMk cId="1573992039" sldId="256"/>
-            <ac:spMk id="1104" creationId="{1522668D-8253-2DF2-841F-181CA4892F52}"/>
-          </ac:spMkLst>
-        </pc:spChg>
-        <pc:spChg chg="del">
-          <ac:chgData name="Fatima Pillosu" userId="a6295d4dc9e22643" providerId="LiveId" clId="{87453732-75AC-4426-B5D3-B7C69C2D4F54}" dt="2026-01-23T06:05:53.912" v="146" actId="478"/>
-          <ac:spMkLst>
-            <pc:docMk/>
-            <pc:sldMk cId="1573992039" sldId="256"/>
-            <ac:spMk id="1107" creationId="{3F9004C2-032E-AE52-1A5E-5FEED9C5F2DC}"/>
-          </ac:spMkLst>
-        </pc:spChg>
-        <pc:spChg chg="del">
-          <ac:chgData name="Fatima Pillosu" userId="a6295d4dc9e22643" providerId="LiveId" clId="{87453732-75AC-4426-B5D3-B7C69C2D4F54}" dt="2026-01-23T06:05:56.023" v="147" actId="478"/>
-          <ac:spMkLst>
-            <pc:docMk/>
-            <pc:sldMk cId="1573992039" sldId="256"/>
-            <ac:spMk id="1114" creationId="{7439BC8B-CAC0-9D56-378A-90AA4CF80489}"/>
-          </ac:spMkLst>
-        </pc:spChg>
-        <pc:spChg chg="del">
-          <ac:chgData name="Fatima Pillosu" userId="a6295d4dc9e22643" providerId="LiveId" clId="{87453732-75AC-4426-B5D3-B7C69C2D4F54}" dt="2026-01-23T06:07:37.998" v="315" actId="478"/>
-          <ac:spMkLst>
-            <pc:docMk/>
-            <pc:sldMk cId="1573992039" sldId="256"/>
-            <ac:spMk id="1115" creationId="{A37FEFDC-7E94-BA80-1E13-1445CE82CED8}"/>
-          </ac:spMkLst>
-        </pc:spChg>
-        <pc:spChg chg="del">
-          <ac:chgData name="Fatima Pillosu" userId="a6295d4dc9e22643" providerId="LiveId" clId="{87453732-75AC-4426-B5D3-B7C69C2D4F54}" dt="2026-01-23T06:07:37.998" v="315" actId="478"/>
-          <ac:spMkLst>
-            <pc:docMk/>
-            <pc:sldMk cId="1573992039" sldId="256"/>
-            <ac:spMk id="1122" creationId="{4FB22F50-5C99-2B5F-1771-1D302FB37FCD}"/>
-          </ac:spMkLst>
-        </pc:spChg>
-        <pc:spChg chg="mod">
-          <ac:chgData name="Fatima Pillosu" userId="a6295d4dc9e22643" providerId="LiveId" clId="{87453732-75AC-4426-B5D3-B7C69C2D4F54}" dt="2026-01-23T06:17:32.551" v="848" actId="1036"/>
-          <ac:spMkLst>
-            <pc:docMk/>
-            <pc:sldMk cId="1573992039" sldId="256"/>
-            <ac:spMk id="1130" creationId="{7B405FDB-437A-E0D9-12DF-F9D7794E6A25}"/>
-          </ac:spMkLst>
-        </pc:spChg>
-        <pc:spChg chg="del">
-          <ac:chgData name="Fatima Pillosu" userId="a6295d4dc9e22643" providerId="LiveId" clId="{87453732-75AC-4426-B5D3-B7C69C2D4F54}" dt="2026-01-23T06:07:37.998" v="315" actId="478"/>
-          <ac:spMkLst>
-            <pc:docMk/>
-            <pc:sldMk cId="1573992039" sldId="256"/>
-            <ac:spMk id="1133" creationId="{EEE42CED-F621-12CD-E62E-637B87C9AF4B}"/>
-          </ac:spMkLst>
-        </pc:spChg>
-        <pc:spChg chg="mod">
-          <ac:chgData name="Fatima Pillosu" userId="a6295d4dc9e22643" providerId="LiveId" clId="{87453732-75AC-4426-B5D3-B7C69C2D4F54}" dt="2026-01-23T06:21:26.461" v="970" actId="1037"/>
-          <ac:spMkLst>
-            <pc:docMk/>
-            <pc:sldMk cId="1573992039" sldId="256"/>
-            <ac:spMk id="1137" creationId="{282A075C-FC14-ED03-372D-F218BF14C255}"/>
-          </ac:spMkLst>
-        </pc:spChg>
-        <pc:spChg chg="mod">
-          <ac:chgData name="Fatima Pillosu" userId="a6295d4dc9e22643" providerId="LiveId" clId="{87453732-75AC-4426-B5D3-B7C69C2D4F54}" dt="2026-01-23T06:17:26.456" v="844" actId="1035"/>
-          <ac:spMkLst>
-            <pc:docMk/>
-            <pc:sldMk cId="1573992039" sldId="256"/>
-            <ac:spMk id="1140" creationId="{BCD7A06A-8268-9635-CFA0-98FB415F69A5}"/>
-          </ac:spMkLst>
-        </pc:spChg>
-        <pc:spChg chg="mod">
-          <ac:chgData name="Fatima Pillosu" userId="a6295d4dc9e22643" providerId="LiveId" clId="{87453732-75AC-4426-B5D3-B7C69C2D4F54}" dt="2026-01-23T06:17:26.456" v="844" actId="1035"/>
-          <ac:spMkLst>
-            <pc:docMk/>
-            <pc:sldMk cId="1573992039" sldId="256"/>
-            <ac:spMk id="1141" creationId="{457A7CA8-58DB-333D-A936-865FFAC656B9}"/>
-          </ac:spMkLst>
-        </pc:spChg>
-        <pc:spChg chg="mod">
-          <ac:chgData name="Fatima Pillosu" userId="a6295d4dc9e22643" providerId="LiveId" clId="{87453732-75AC-4426-B5D3-B7C69C2D4F54}" dt="2026-01-23T06:15:14.491" v="749" actId="1036"/>
-          <ac:spMkLst>
-            <pc:docMk/>
-            <pc:sldMk cId="1573992039" sldId="256"/>
-            <ac:spMk id="1142" creationId="{5CA4D6A9-0792-5E29-DA62-A5DBF037B22B}"/>
-          </ac:spMkLst>
-        </pc:spChg>
-        <pc:spChg chg="mod">
-          <ac:chgData name="Fatima Pillosu" userId="a6295d4dc9e22643" providerId="LiveId" clId="{87453732-75AC-4426-B5D3-B7C69C2D4F54}" dt="2026-01-23T06:10:12.873" v="547" actId="1038"/>
-          <ac:spMkLst>
-            <pc:docMk/>
-            <pc:sldMk cId="1573992039" sldId="256"/>
-            <ac:spMk id="1143" creationId="{FBFCFFE0-3901-7793-A62D-7147545489BE}"/>
-          </ac:spMkLst>
-        </pc:spChg>
-        <pc:spChg chg="mod">
-          <ac:chgData name="Fatima Pillosu" userId="a6295d4dc9e22643" providerId="LiveId" clId="{87453732-75AC-4426-B5D3-B7C69C2D4F54}" dt="2026-01-23T06:10:12.873" v="547" actId="1038"/>
-          <ac:spMkLst>
-            <pc:docMk/>
-            <pc:sldMk cId="1573992039" sldId="256"/>
-            <ac:spMk id="1144" creationId="{94B0C2B1-31E6-1978-E467-2D3B669EA695}"/>
-          </ac:spMkLst>
-        </pc:spChg>
-        <pc:spChg chg="add del mod">
-          <ac:chgData name="Fatima Pillosu" userId="a6295d4dc9e22643" providerId="LiveId" clId="{87453732-75AC-4426-B5D3-B7C69C2D4F54}" dt="2026-01-23T06:22:09.035" v="1010" actId="21"/>
-          <ac:spMkLst>
-            <pc:docMk/>
-            <pc:sldMk cId="1573992039" sldId="256"/>
-            <ac:spMk id="1145" creationId="{0D756F47-6773-61EE-FBB2-2FD6EA2404A7}"/>
-          </ac:spMkLst>
-        </pc:spChg>
-        <pc:spChg chg="mod">
-          <ac:chgData name="Fatima Pillosu" userId="a6295d4dc9e22643" providerId="LiveId" clId="{87453732-75AC-4426-B5D3-B7C69C2D4F54}" dt="2026-01-23T06:17:26.456" v="844" actId="1035"/>
-          <ac:spMkLst>
-            <pc:docMk/>
-            <pc:sldMk cId="1573992039" sldId="256"/>
-            <ac:spMk id="1147" creationId="{8802879B-B9A8-7464-3859-16BA11BE8AAC}"/>
-          </ac:spMkLst>
-        </pc:spChg>
-        <pc:spChg chg="mod">
-          <ac:chgData name="Fatima Pillosu" userId="a6295d4dc9e22643" providerId="LiveId" clId="{87453732-75AC-4426-B5D3-B7C69C2D4F54}" dt="2026-01-23T06:10:12.873" v="547" actId="1038"/>
-          <ac:spMkLst>
-            <pc:docMk/>
-            <pc:sldMk cId="1573992039" sldId="256"/>
-            <ac:spMk id="1148" creationId="{D255BC9A-40E1-A5E2-0559-0A7205B39793}"/>
-          </ac:spMkLst>
-        </pc:spChg>
-        <pc:spChg chg="mod">
-          <ac:chgData name="Fatima Pillosu" userId="a6295d4dc9e22643" providerId="LiveId" clId="{87453732-75AC-4426-B5D3-B7C69C2D4F54}" dt="2026-01-23T06:10:12.873" v="547" actId="1038"/>
-          <ac:spMkLst>
-            <pc:docMk/>
-            <pc:sldMk cId="1573992039" sldId="256"/>
-            <ac:spMk id="1149" creationId="{7CCCA3AC-3B8B-DA56-0C7D-D11E0731180C}"/>
-          </ac:spMkLst>
-        </pc:spChg>
-        <pc:spChg chg="mod">
-          <ac:chgData name="Fatima Pillosu" userId="a6295d4dc9e22643" providerId="LiveId" clId="{87453732-75AC-4426-B5D3-B7C69C2D4F54}" dt="2026-01-23T06:16:40.097" v="811" actId="1036"/>
-          <ac:spMkLst>
-            <pc:docMk/>
-            <pc:sldMk cId="1573992039" sldId="256"/>
-            <ac:spMk id="1150" creationId="{E5DB3464-82F8-B511-F8CC-E4499CE0AFE2}"/>
-          </ac:spMkLst>
-        </pc:spChg>
-        <pc:spChg chg="del">
-          <ac:chgData name="Fatima Pillosu" userId="a6295d4dc9e22643" providerId="LiveId" clId="{87453732-75AC-4426-B5D3-B7C69C2D4F54}" dt="2026-01-23T06:08:44.352" v="362" actId="478"/>
-          <ac:spMkLst>
-            <pc:docMk/>
-            <pc:sldMk cId="1573992039" sldId="256"/>
-            <ac:spMk id="1152" creationId="{3DF81A28-CD90-A483-6597-76D5C1E3BBFA}"/>
-          </ac:spMkLst>
-        </pc:spChg>
-        <pc:spChg chg="mod">
-          <ac:chgData name="Fatima Pillosu" userId="a6295d4dc9e22643" providerId="LiveId" clId="{87453732-75AC-4426-B5D3-B7C69C2D4F54}" dt="2026-01-23T06:21:05.469" v="927" actId="1037"/>
-          <ac:spMkLst>
-            <pc:docMk/>
-            <pc:sldMk cId="1573992039" sldId="256"/>
-            <ac:spMk id="1153" creationId="{854C57C6-B1CB-81E6-BE42-54BBCAEE6F6E}"/>
-          </ac:spMkLst>
-        </pc:spChg>
-        <pc:spChg chg="mod">
-          <ac:chgData name="Fatima Pillosu" userId="a6295d4dc9e22643" providerId="LiveId" clId="{87453732-75AC-4426-B5D3-B7C69C2D4F54}" dt="2026-01-23T06:16:04.064" v="772" actId="1037"/>
-          <ac:spMkLst>
-            <pc:docMk/>
-            <pc:sldMk cId="1573992039" sldId="256"/>
-            <ac:spMk id="1154" creationId="{80787000-C599-E543-34BD-DD0D2598B666}"/>
-          </ac:spMkLst>
-        </pc:spChg>
-        <pc:spChg chg="mod">
-          <ac:chgData name="Fatima Pillosu" userId="a6295d4dc9e22643" providerId="LiveId" clId="{87453732-75AC-4426-B5D3-B7C69C2D4F54}" dt="2026-01-23T06:21:05.469" v="927" actId="1037"/>
-          <ac:spMkLst>
-            <pc:docMk/>
-            <pc:sldMk cId="1573992039" sldId="256"/>
-            <ac:spMk id="1155" creationId="{76947797-C448-1C55-2DBC-142C727E469F}"/>
-          </ac:spMkLst>
-        </pc:spChg>
-        <pc:spChg chg="mod">
-          <ac:chgData name="Fatima Pillosu" userId="a6295d4dc9e22643" providerId="LiveId" clId="{87453732-75AC-4426-B5D3-B7C69C2D4F54}" dt="2026-01-23T06:21:05.469" v="927" actId="1037"/>
-          <ac:spMkLst>
-            <pc:docMk/>
-            <pc:sldMk cId="1573992039" sldId="256"/>
-            <ac:spMk id="1156" creationId="{07256CEB-6233-6ADF-9393-C851AE06C283}"/>
-          </ac:spMkLst>
-        </pc:spChg>
-        <pc:spChg chg="mod">
-          <ac:chgData name="Fatima Pillosu" userId="a6295d4dc9e22643" providerId="LiveId" clId="{87453732-75AC-4426-B5D3-B7C69C2D4F54}" dt="2026-01-23T06:21:05.469" v="927" actId="1037"/>
-          <ac:spMkLst>
-            <pc:docMk/>
-            <pc:sldMk cId="1573992039" sldId="256"/>
-            <ac:spMk id="1157" creationId="{108B4DC9-CA15-ABD1-9E75-1F89C427C22C}"/>
-          </ac:spMkLst>
-        </pc:spChg>
-        <pc:spChg chg="mod">
-          <ac:chgData name="Fatima Pillosu" userId="a6295d4dc9e22643" providerId="LiveId" clId="{87453732-75AC-4426-B5D3-B7C69C2D4F54}" dt="2026-01-23T06:16:04.064" v="772" actId="1037"/>
-          <ac:spMkLst>
-            <pc:docMk/>
-            <pc:sldMk cId="1573992039" sldId="256"/>
-            <ac:spMk id="1158" creationId="{E51641AA-6F79-6900-66D4-9E8509B65255}"/>
-          </ac:spMkLst>
-        </pc:spChg>
-        <pc:spChg chg="mod">
-          <ac:chgData name="Fatima Pillosu" userId="a6295d4dc9e22643" providerId="LiveId" clId="{87453732-75AC-4426-B5D3-B7C69C2D4F54}" dt="2026-01-23T06:21:05.469" v="927" actId="1037"/>
-          <ac:spMkLst>
-            <pc:docMk/>
-            <pc:sldMk cId="1573992039" sldId="256"/>
-            <ac:spMk id="1159" creationId="{28602834-4445-244F-EBAA-6A145FEF4FE1}"/>
-          </ac:spMkLst>
-        </pc:spChg>
-        <pc:spChg chg="mod topLvl">
-          <ac:chgData name="Fatima Pillosu" userId="a6295d4dc9e22643" providerId="LiveId" clId="{87453732-75AC-4426-B5D3-B7C69C2D4F54}" dt="2026-01-23T06:21:10.382" v="931" actId="1036"/>
-          <ac:spMkLst>
-            <pc:docMk/>
-            <pc:sldMk cId="1573992039" sldId="256"/>
-            <ac:spMk id="1160" creationId="{5F81FB1E-F02B-3930-7760-882160F38BA4}"/>
-          </ac:spMkLst>
-        </pc:spChg>
-        <pc:spChg chg="del">
-          <ac:chgData name="Fatima Pillosu" userId="a6295d4dc9e22643" providerId="LiveId" clId="{87453732-75AC-4426-B5D3-B7C69C2D4F54}" dt="2026-01-23T06:08:44.352" v="362" actId="478"/>
-          <ac:spMkLst>
-            <pc:docMk/>
-            <pc:sldMk cId="1573992039" sldId="256"/>
-            <ac:spMk id="1161" creationId="{0215C983-B1C6-6E89-8C74-B7C652941C14}"/>
-          </ac:spMkLst>
-        </pc:spChg>
-        <pc:spChg chg="del mod">
-          <ac:chgData name="Fatima Pillosu" userId="a6295d4dc9e22643" providerId="LiveId" clId="{87453732-75AC-4426-B5D3-B7C69C2D4F54}" dt="2026-01-23T06:22:09.035" v="1010" actId="21"/>
-          <ac:spMkLst>
-            <pc:docMk/>
-            <pc:sldMk cId="1573992039" sldId="256"/>
-            <ac:spMk id="1162" creationId="{C401F5C3-E8F7-BAB8-A8F7-724890C219C7}"/>
-          </ac:spMkLst>
-        </pc:spChg>
-        <pc:spChg chg="mod">
-          <ac:chgData name="Fatima Pillosu" userId="a6295d4dc9e22643" providerId="LiveId" clId="{87453732-75AC-4426-B5D3-B7C69C2D4F54}" dt="2026-01-23T06:21:26.461" v="970" actId="1037"/>
-          <ac:spMkLst>
-            <pc:docMk/>
-            <pc:sldMk cId="1573992039" sldId="256"/>
-            <ac:spMk id="1163" creationId="{99F67917-9AC9-8FE9-8BA3-F13C15B3B3CD}"/>
-          </ac:spMkLst>
-        </pc:spChg>
-        <pc:spChg chg="mod">
-          <ac:chgData name="Fatima Pillosu" userId="a6295d4dc9e22643" providerId="LiveId" clId="{87453732-75AC-4426-B5D3-B7C69C2D4F54}" dt="2026-01-23T06:21:53.395" v="988" actId="1037"/>
-          <ac:spMkLst>
-            <pc:docMk/>
-            <pc:sldMk cId="1573992039" sldId="256"/>
-            <ac:spMk id="1164" creationId="{C8C4BEE6-6376-0E74-4150-BF74DE0D27C7}"/>
-          </ac:spMkLst>
-        </pc:spChg>
-        <pc:spChg chg="mod">
-          <ac:chgData name="Fatima Pillosu" userId="a6295d4dc9e22643" providerId="LiveId" clId="{87453732-75AC-4426-B5D3-B7C69C2D4F54}" dt="2026-01-23T06:21:59.559" v="1009" actId="1038"/>
-          <ac:spMkLst>
-            <pc:docMk/>
-            <pc:sldMk cId="1573992039" sldId="256"/>
-            <ac:spMk id="1165" creationId="{31C77472-B4C1-1507-81B9-962B732F7D61}"/>
-          </ac:spMkLst>
-        </pc:spChg>
-        <pc:spChg chg="mod">
-          <ac:chgData name="Fatima Pillosu" userId="a6295d4dc9e22643" providerId="LiveId" clId="{87453732-75AC-4426-B5D3-B7C69C2D4F54}" dt="2026-01-23T06:21:26.461" v="970" actId="1037"/>
-          <ac:spMkLst>
-            <pc:docMk/>
-            <pc:sldMk cId="1573992039" sldId="256"/>
-            <ac:spMk id="1167" creationId="{38B04327-CBC3-696A-FEE2-E4AA2D314282}"/>
-          </ac:spMkLst>
-        </pc:spChg>
-        <pc:spChg chg="mod">
-          <ac:chgData name="Fatima Pillosu" userId="a6295d4dc9e22643" providerId="LiveId" clId="{87453732-75AC-4426-B5D3-B7C69C2D4F54}" dt="2026-01-23T06:21:53.395" v="988" actId="1037"/>
-          <ac:spMkLst>
-            <pc:docMk/>
-            <pc:sldMk cId="1573992039" sldId="256"/>
-            <ac:spMk id="1168" creationId="{54066B8D-FAB6-E393-A31E-DBD9964AA0F3}"/>
-          </ac:spMkLst>
-        </pc:spChg>
-        <pc:spChg chg="mod">
-          <ac:chgData name="Fatima Pillosu" userId="a6295d4dc9e22643" providerId="LiveId" clId="{87453732-75AC-4426-B5D3-B7C69C2D4F54}" dt="2026-01-23T06:21:53.395" v="988" actId="1037"/>
-          <ac:spMkLst>
-            <pc:docMk/>
-            <pc:sldMk cId="1573992039" sldId="256"/>
-            <ac:spMk id="1169" creationId="{696A8281-B551-088A-C0CF-AD4F0B2FA950}"/>
-          </ac:spMkLst>
-        </pc:spChg>
-        <pc:spChg chg="mod">
-          <ac:chgData name="Fatima Pillosu" userId="a6295d4dc9e22643" providerId="LiveId" clId="{87453732-75AC-4426-B5D3-B7C69C2D4F54}" dt="2026-01-23T06:21:26.461" v="970" actId="1037"/>
-          <ac:spMkLst>
-            <pc:docMk/>
-            <pc:sldMk cId="1573992039" sldId="256"/>
-            <ac:spMk id="1170" creationId="{89AAB22A-494B-5CBA-B74A-3344AA54BD7D}"/>
-          </ac:spMkLst>
-        </pc:spChg>
-        <pc:spChg chg="mod">
-          <ac:chgData name="Fatima Pillosu" userId="a6295d4dc9e22643" providerId="LiveId" clId="{87453732-75AC-4426-B5D3-B7C69C2D4F54}" dt="2026-01-23T06:21:16.579" v="938" actId="1035"/>
-          <ac:spMkLst>
-            <pc:docMk/>
-            <pc:sldMk cId="1573992039" sldId="256"/>
-            <ac:spMk id="1182" creationId="{181CF5A4-A6E8-DE3E-D312-EF059C34A5F1}"/>
-          </ac:spMkLst>
-        </pc:spChg>
-        <pc:spChg chg="del">
-          <ac:chgData name="Fatima Pillosu" userId="a6295d4dc9e22643" providerId="LiveId" clId="{87453732-75AC-4426-B5D3-B7C69C2D4F54}" dt="2026-01-23T06:07:37.998" v="315" actId="478"/>
-          <ac:spMkLst>
-            <pc:docMk/>
-            <pc:sldMk cId="1573992039" sldId="256"/>
-            <ac:spMk id="1183" creationId="{8C641901-B554-CFD9-F097-2D3CBA030DFC}"/>
-          </ac:spMkLst>
-        </pc:spChg>
-        <pc:spChg chg="del">
-          <ac:chgData name="Fatima Pillosu" userId="a6295d4dc9e22643" providerId="LiveId" clId="{87453732-75AC-4426-B5D3-B7C69C2D4F54}" dt="2026-01-23T06:08:44.352" v="362" actId="478"/>
-          <ac:spMkLst>
-            <pc:docMk/>
-            <pc:sldMk cId="1573992039" sldId="256"/>
-            <ac:spMk id="1184" creationId="{B31D2BC5-9FE2-AC33-1FD7-4F30953E4112}"/>
-          </ac:spMkLst>
-        </pc:spChg>
-        <pc:spChg chg="del">
-          <ac:chgData name="Fatima Pillosu" userId="a6295d4dc9e22643" providerId="LiveId" clId="{87453732-75AC-4426-B5D3-B7C69C2D4F54}" dt="2026-01-23T06:08:44.352" v="362" actId="478"/>
-          <ac:spMkLst>
-            <pc:docMk/>
-            <pc:sldMk cId="1573992039" sldId="256"/>
-            <ac:spMk id="1185" creationId="{090F0BD1-9587-ABAE-9C45-FC88C5817D07}"/>
-          </ac:spMkLst>
-        </pc:spChg>
-        <pc:spChg chg="del">
-          <ac:chgData name="Fatima Pillosu" userId="a6295d4dc9e22643" providerId="LiveId" clId="{87453732-75AC-4426-B5D3-B7C69C2D4F54}" dt="2026-01-23T06:07:37.998" v="315" actId="478"/>
-          <ac:spMkLst>
-            <pc:docMk/>
-            <pc:sldMk cId="1573992039" sldId="256"/>
-            <ac:spMk id="1186" creationId="{13ED9C4B-B891-6D43-D74B-B8DE8A400DAB}"/>
-          </ac:spMkLst>
-        </pc:spChg>
-        <pc:spChg chg="del">
-          <ac:chgData name="Fatima Pillosu" userId="a6295d4dc9e22643" providerId="LiveId" clId="{87453732-75AC-4426-B5D3-B7C69C2D4F54}" dt="2026-01-23T06:17:51.954" v="849" actId="478"/>
-          <ac:spMkLst>
-            <pc:docMk/>
-            <pc:sldMk cId="1573992039" sldId="256"/>
-            <ac:spMk id="1187" creationId="{4F124D69-8C8F-0465-1158-5890B8CA6C76}"/>
-          </ac:spMkLst>
-        </pc:spChg>
-        <pc:spChg chg="del">
-          <ac:chgData name="Fatima Pillosu" userId="a6295d4dc9e22643" providerId="LiveId" clId="{87453732-75AC-4426-B5D3-B7C69C2D4F54}" dt="2026-01-23T06:07:37.998" v="315" actId="478"/>
-          <ac:spMkLst>
-            <pc:docMk/>
-            <pc:sldMk cId="1573992039" sldId="256"/>
-            <ac:spMk id="1188" creationId="{79684876-645E-704D-8926-747B6760BCDA}"/>
-          </ac:spMkLst>
-        </pc:spChg>
-        <pc:spChg chg="mod">
-          <ac:chgData name="Fatima Pillosu" userId="a6295d4dc9e22643" providerId="LiveId" clId="{87453732-75AC-4426-B5D3-B7C69C2D4F54}" dt="2026-01-23T06:34:35.046" v="1465" actId="1076"/>
-          <ac:spMkLst>
-            <pc:docMk/>
-            <pc:sldMk cId="1573992039" sldId="256"/>
-            <ac:spMk id="1190" creationId="{2BAE837D-32FC-97CF-019E-838E27B3CC29}"/>
-          </ac:spMkLst>
-        </pc:spChg>
-        <pc:spChg chg="del mod">
-          <ac:chgData name="Fatima Pillosu" userId="a6295d4dc9e22643" providerId="LiveId" clId="{87453732-75AC-4426-B5D3-B7C69C2D4F54}" dt="2026-01-23T06:35:24.603" v="1469" actId="21"/>
-          <ac:spMkLst>
-            <pc:docMk/>
-            <pc:sldMk cId="1573992039" sldId="256"/>
-            <ac:spMk id="1191" creationId="{9958E352-CA91-7654-2E99-B1A4B437CC31}"/>
-          </ac:spMkLst>
-        </pc:spChg>
-        <pc:spChg chg="add mod">
-          <ac:chgData name="Fatima Pillosu" userId="a6295d4dc9e22643" providerId="LiveId" clId="{87453732-75AC-4426-B5D3-B7C69C2D4F54}" dt="2026-01-23T06:34:35.046" v="1465" actId="1076"/>
-          <ac:spMkLst>
-            <pc:docMk/>
-            <pc:sldMk cId="1573992039" sldId="256"/>
-            <ac:spMk id="1192" creationId="{E318B0CD-B389-D58D-3EAB-C464FDE2BBDF}"/>
-          </ac:spMkLst>
-        </pc:spChg>
-        <pc:spChg chg="mod">
-          <ac:chgData name="Fatima Pillosu" userId="a6295d4dc9e22643" providerId="LiveId" clId="{87453732-75AC-4426-B5D3-B7C69C2D4F54}" dt="2026-01-23T06:34:35.046" v="1465" actId="1076"/>
-          <ac:spMkLst>
-            <pc:docMk/>
-            <pc:sldMk cId="1573992039" sldId="256"/>
-            <ac:spMk id="1193" creationId="{AAE01415-D4C9-E837-A004-72122191A783}"/>
-          </ac:spMkLst>
-        </pc:spChg>
-        <pc:spChg chg="mod">
-          <ac:chgData name="Fatima Pillosu" userId="a6295d4dc9e22643" providerId="LiveId" clId="{87453732-75AC-4426-B5D3-B7C69C2D4F54}" dt="2026-01-23T06:34:42.194" v="1466" actId="1076"/>
-          <ac:spMkLst>
-            <pc:docMk/>
-            <pc:sldMk cId="1573992039" sldId="256"/>
-            <ac:spMk id="1195" creationId="{C62D19F3-9A9F-B2C2-2BB9-CB18EFFAADFA}"/>
-          </ac:spMkLst>
-        </pc:spChg>
-        <pc:spChg chg="mod">
-          <ac:chgData name="Fatima Pillosu" userId="a6295d4dc9e22643" providerId="LiveId" clId="{87453732-75AC-4426-B5D3-B7C69C2D4F54}" dt="2026-01-23T06:34:35.046" v="1465" actId="1076"/>
-          <ac:spMkLst>
-            <pc:docMk/>
-            <pc:sldMk cId="1573992039" sldId="256"/>
-            <ac:spMk id="1196" creationId="{E400DCAC-CC0F-0CD9-3009-10B18A31A7E3}"/>
-          </ac:spMkLst>
-        </pc:spChg>
-        <pc:spChg chg="add del mod">
-          <ac:chgData name="Fatima Pillosu" userId="a6295d4dc9e22643" providerId="LiveId" clId="{87453732-75AC-4426-B5D3-B7C69C2D4F54}" dt="2026-01-23T06:32:50.510" v="1453" actId="478"/>
-          <ac:spMkLst>
-            <pc:docMk/>
-            <pc:sldMk cId="1573992039" sldId="256"/>
-            <ac:spMk id="1197" creationId="{7B405FDB-437A-E0D9-12DF-F9D7794E6A25}"/>
-          </ac:spMkLst>
-        </pc:spChg>
-        <pc:spChg chg="mod">
-          <ac:chgData name="Fatima Pillosu" userId="a6295d4dc9e22643" providerId="LiveId" clId="{87453732-75AC-4426-B5D3-B7C69C2D4F54}" dt="2026-01-23T06:31:42.437" v="1417" actId="1037"/>
-          <ac:spMkLst>
-            <pc:docMk/>
-            <pc:sldMk cId="1573992039" sldId="256"/>
-            <ac:spMk id="1198" creationId="{282A075C-FC14-ED03-372D-F218BF14C255}"/>
-          </ac:spMkLst>
-        </pc:spChg>
-        <pc:spChg chg="del">
-          <ac:chgData name="Fatima Pillosu" userId="a6295d4dc9e22643" providerId="LiveId" clId="{87453732-75AC-4426-B5D3-B7C69C2D4F54}" dt="2026-01-23T06:35:24.603" v="1469" actId="21"/>
-          <ac:spMkLst>
-            <pc:docMk/>
-            <pc:sldMk cId="1573992039" sldId="256"/>
-            <ac:spMk id="1203" creationId="{94B0C2B1-31E6-1978-E467-2D3B669EA695}"/>
-          </ac:spMkLst>
-        </pc:spChg>
-        <pc:spChg chg="mod">
-          <ac:chgData name="Fatima Pillosu" userId="a6295d4dc9e22643" providerId="LiveId" clId="{87453732-75AC-4426-B5D3-B7C69C2D4F54}" dt="2026-01-23T06:29:30.682" v="1354" actId="1037"/>
-          <ac:spMkLst>
-            <pc:docMk/>
-            <pc:sldMk cId="1573992039" sldId="256"/>
-            <ac:spMk id="1204" creationId="{0D756F47-6773-61EE-FBB2-2FD6EA2404A7}"/>
-          </ac:spMkLst>
-        </pc:spChg>
-        <pc:spChg chg="mod">
-          <ac:chgData name="Fatima Pillosu" userId="a6295d4dc9e22643" providerId="LiveId" clId="{87453732-75AC-4426-B5D3-B7C69C2D4F54}" dt="2026-01-23T06:27:46.345" v="1303" actId="1076"/>
-          <ac:spMkLst>
-            <pc:docMk/>
-            <pc:sldMk cId="1573992039" sldId="256"/>
-            <ac:spMk id="1209" creationId="{E5DB3464-82F8-B511-F8CC-E4499CE0AFE2}"/>
-          </ac:spMkLst>
-        </pc:spChg>
-        <pc:spChg chg="del mod">
-          <ac:chgData name="Fatima Pillosu" userId="a6295d4dc9e22643" providerId="LiveId" clId="{87453732-75AC-4426-B5D3-B7C69C2D4F54}" dt="2026-01-23T06:35:24.603" v="1469" actId="21"/>
-          <ac:spMkLst>
-            <pc:docMk/>
-            <pc:sldMk cId="1573992039" sldId="256"/>
-            <ac:spMk id="1210" creationId="{854C57C6-B1CB-81E6-BE42-54BBCAEE6F6E}"/>
-          </ac:spMkLst>
-        </pc:spChg>
-        <pc:spChg chg="mod">
-          <ac:chgData name="Fatima Pillosu" userId="a6295d4dc9e22643" providerId="LiveId" clId="{87453732-75AC-4426-B5D3-B7C69C2D4F54}" dt="2026-01-23T06:29:30.682" v="1354" actId="1037"/>
-          <ac:spMkLst>
-            <pc:docMk/>
-            <pc:sldMk cId="1573992039" sldId="256"/>
-            <ac:spMk id="1211" creationId="{80787000-C599-E543-34BD-DD0D2598B666}"/>
-          </ac:spMkLst>
-        </pc:spChg>
-        <pc:spChg chg="mod">
-          <ac:chgData name="Fatima Pillosu" userId="a6295d4dc9e22643" providerId="LiveId" clId="{87453732-75AC-4426-B5D3-B7C69C2D4F54}" dt="2026-01-23T06:28:55.409" v="1328" actId="1037"/>
-          <ac:spMkLst>
-            <pc:docMk/>
-            <pc:sldMk cId="1573992039" sldId="256"/>
-            <ac:spMk id="1212" creationId="{76947797-C448-1C55-2DBC-142C727E469F}"/>
-          </ac:spMkLst>
-        </pc:spChg>
-        <pc:spChg chg="mod">
-          <ac:chgData name="Fatima Pillosu" userId="a6295d4dc9e22643" providerId="LiveId" clId="{87453732-75AC-4426-B5D3-B7C69C2D4F54}" dt="2026-01-23T06:28:55.409" v="1328" actId="1037"/>
-          <ac:spMkLst>
-            <pc:docMk/>
-            <pc:sldMk cId="1573992039" sldId="256"/>
-            <ac:spMk id="1213" creationId="{07256CEB-6233-6ADF-9393-C851AE06C283}"/>
-          </ac:spMkLst>
-        </pc:spChg>
-        <pc:spChg chg="mod">
-          <ac:chgData name="Fatima Pillosu" userId="a6295d4dc9e22643" providerId="LiveId" clId="{87453732-75AC-4426-B5D3-B7C69C2D4F54}" dt="2026-01-23T06:28:55.409" v="1328" actId="1037"/>
-          <ac:spMkLst>
-            <pc:docMk/>
-            <pc:sldMk cId="1573992039" sldId="256"/>
-            <ac:spMk id="1214" creationId="{108B4DC9-CA15-ABD1-9E75-1F89C427C22C}"/>
-          </ac:spMkLst>
-        </pc:spChg>
-        <pc:spChg chg="mod">
-          <ac:chgData name="Fatima Pillosu" userId="a6295d4dc9e22643" providerId="LiveId" clId="{87453732-75AC-4426-B5D3-B7C69C2D4F54}" dt="2026-01-23T06:29:30.682" v="1354" actId="1037"/>
-          <ac:spMkLst>
-            <pc:docMk/>
-            <pc:sldMk cId="1573992039" sldId="256"/>
-            <ac:spMk id="1215" creationId="{E51641AA-6F79-6900-66D4-9E8509B65255}"/>
-          </ac:spMkLst>
-        </pc:spChg>
-        <pc:spChg chg="add del mod">
-          <ac:chgData name="Fatima Pillosu" userId="a6295d4dc9e22643" providerId="LiveId" clId="{87453732-75AC-4426-B5D3-B7C69C2D4F54}" dt="2026-01-23T06:28:45.469" v="1306" actId="478"/>
-          <ac:spMkLst>
-            <pc:docMk/>
-            <pc:sldMk cId="1573992039" sldId="256"/>
-            <ac:spMk id="1216" creationId="{193477AB-68FC-C300-DD3D-372A77A28986}"/>
-          </ac:spMkLst>
-        </pc:spChg>
-        <pc:spChg chg="add mod">
-          <ac:chgData name="Fatima Pillosu" userId="a6295d4dc9e22643" providerId="LiveId" clId="{87453732-75AC-4426-B5D3-B7C69C2D4F54}" dt="2026-01-23T06:29:59.946" v="1358" actId="1076"/>
-          <ac:spMkLst>
-            <pc:docMk/>
-            <pc:sldMk cId="1573992039" sldId="256"/>
-            <ac:spMk id="1217" creationId="{1F320868-9DD0-27CF-9FA6-277232DD29C6}"/>
-          </ac:spMkLst>
-        </pc:spChg>
-        <pc:spChg chg="add mod">
-          <ac:chgData name="Fatima Pillosu" userId="a6295d4dc9e22643" providerId="LiveId" clId="{87453732-75AC-4426-B5D3-B7C69C2D4F54}" dt="2026-01-23T06:29:59.946" v="1358" actId="1076"/>
-          <ac:spMkLst>
-            <pc:docMk/>
-            <pc:sldMk cId="1573992039" sldId="256"/>
-            <ac:spMk id="1218" creationId="{0E1E31B6-12D2-7F6F-5AB2-C289DFA1A572}"/>
-          </ac:spMkLst>
-        </pc:spChg>
-        <pc:spChg chg="add mod">
-          <ac:chgData name="Fatima Pillosu" userId="a6295d4dc9e22643" providerId="LiveId" clId="{87453732-75AC-4426-B5D3-B7C69C2D4F54}" dt="2026-01-23T06:29:59.946" v="1358" actId="1076"/>
-          <ac:spMkLst>
-            <pc:docMk/>
-            <pc:sldMk cId="1573992039" sldId="256"/>
-            <ac:spMk id="1219" creationId="{7E066DE1-C414-FF1A-8DA4-43E44DEAD816}"/>
-          </ac:spMkLst>
-        </pc:spChg>
-        <pc:spChg chg="add mod">
-          <ac:chgData name="Fatima Pillosu" userId="a6295d4dc9e22643" providerId="LiveId" clId="{87453732-75AC-4426-B5D3-B7C69C2D4F54}" dt="2026-01-23T06:29:59.946" v="1358" actId="1076"/>
-          <ac:spMkLst>
-            <pc:docMk/>
-            <pc:sldMk cId="1573992039" sldId="256"/>
-            <ac:spMk id="1220" creationId="{17E23D5D-0602-2FE5-EB41-95964AC860AA}"/>
-          </ac:spMkLst>
-        </pc:spChg>
-        <pc:spChg chg="add mod">
-          <ac:chgData name="Fatima Pillosu" userId="a6295d4dc9e22643" providerId="LiveId" clId="{87453732-75AC-4426-B5D3-B7C69C2D4F54}" dt="2026-01-23T06:29:59.946" v="1358" actId="1076"/>
-          <ac:spMkLst>
-            <pc:docMk/>
-            <pc:sldMk cId="1573992039" sldId="256"/>
-            <ac:spMk id="1221" creationId="{99FA423C-06DF-9B60-C523-9D2A31C4D0AC}"/>
-          </ac:spMkLst>
-        </pc:spChg>
-        <pc:spChg chg="add mod">
-          <ac:chgData name="Fatima Pillosu" userId="a6295d4dc9e22643" providerId="LiveId" clId="{87453732-75AC-4426-B5D3-B7C69C2D4F54}" dt="2026-01-23T06:29:59.946" v="1358" actId="1076"/>
-          <ac:spMkLst>
-            <pc:docMk/>
-            <pc:sldMk cId="1573992039" sldId="256"/>
-            <ac:spMk id="1222" creationId="{C54329A9-6222-C265-B716-1FFEA6F79E15}"/>
-          </ac:spMkLst>
-        </pc:spChg>
-        <pc:spChg chg="add mod">
-          <ac:chgData name="Fatima Pillosu" userId="a6295d4dc9e22643" providerId="LiveId" clId="{87453732-75AC-4426-B5D3-B7C69C2D4F54}" dt="2026-01-23T06:29:59.946" v="1358" actId="1076"/>
-          <ac:spMkLst>
-            <pc:docMk/>
-            <pc:sldMk cId="1573992039" sldId="256"/>
-            <ac:spMk id="1223" creationId="{8F8D233F-548F-CE6C-4AE1-4CCEA7A10B06}"/>
-          </ac:spMkLst>
-        </pc:spChg>
-        <pc:spChg chg="add mod">
-          <ac:chgData name="Fatima Pillosu" userId="a6295d4dc9e22643" providerId="LiveId" clId="{87453732-75AC-4426-B5D3-B7C69C2D4F54}" dt="2026-01-23T06:29:59.946" v="1358" actId="1076"/>
-          <ac:spMkLst>
-            <pc:docMk/>
-            <pc:sldMk cId="1573992039" sldId="256"/>
-            <ac:spMk id="1224" creationId="{FE1F1E5C-DE1D-3AB6-259D-F8F24450ECBA}"/>
-          </ac:spMkLst>
-        </pc:spChg>
-        <pc:spChg chg="add mod">
-          <ac:chgData name="Fatima Pillosu" userId="a6295d4dc9e22643" providerId="LiveId" clId="{87453732-75AC-4426-B5D3-B7C69C2D4F54}" dt="2026-01-23T06:29:59.946" v="1358" actId="1076"/>
-          <ac:spMkLst>
-            <pc:docMk/>
-            <pc:sldMk cId="1573992039" sldId="256"/>
-            <ac:spMk id="1228" creationId="{ABBA72E7-811A-3BB5-7B9F-431AC55186B8}"/>
-          </ac:spMkLst>
-        </pc:spChg>
-        <pc:spChg chg="add mod">
-          <ac:chgData name="Fatima Pillosu" userId="a6295d4dc9e22643" providerId="LiveId" clId="{87453732-75AC-4426-B5D3-B7C69C2D4F54}" dt="2026-01-23T06:30:03.097" v="1362" actId="20577"/>
-          <ac:spMkLst>
-            <pc:docMk/>
-            <pc:sldMk cId="1573992039" sldId="256"/>
-            <ac:spMk id="1229" creationId="{84F97439-CB5D-012E-DA21-5F1489B9ADC1}"/>
-          </ac:spMkLst>
-        </pc:spChg>
-        <pc:spChg chg="add mod">
-          <ac:chgData name="Fatima Pillosu" userId="a6295d4dc9e22643" providerId="LiveId" clId="{87453732-75AC-4426-B5D3-B7C69C2D4F54}" dt="2026-01-23T06:30:58.541" v="1383" actId="206"/>
-          <ac:spMkLst>
-            <pc:docMk/>
-            <pc:sldMk cId="1573992039" sldId="256"/>
-            <ac:spMk id="1230" creationId="{FFC644DB-2ACD-2F64-2DFD-FF962E029B98}"/>
-          </ac:spMkLst>
-        </pc:spChg>
-        <pc:spChg chg="add mod">
-          <ac:chgData name="Fatima Pillosu" userId="a6295d4dc9e22643" providerId="LiveId" clId="{87453732-75AC-4426-B5D3-B7C69C2D4F54}" dt="2026-01-23T06:34:29.074" v="1464" actId="1076"/>
-          <ac:spMkLst>
-            <pc:docMk/>
-            <pc:sldMk cId="1573992039" sldId="256"/>
-            <ac:spMk id="1231" creationId="{CD50AF3A-89D8-632A-0AAB-9BB5D552B446}"/>
-          </ac:spMkLst>
-        </pc:spChg>
-        <pc:spChg chg="add del mod">
-          <ac:chgData name="Fatima Pillosu" userId="a6295d4dc9e22643" providerId="LiveId" clId="{87453732-75AC-4426-B5D3-B7C69C2D4F54}" dt="2026-01-23T06:35:24.603" v="1469" actId="21"/>
-          <ac:spMkLst>
-            <pc:docMk/>
-            <pc:sldMk cId="1573992039" sldId="256"/>
-            <ac:spMk id="1233" creationId="{115E43C9-51F3-752F-21A4-D2C95BE0808B}"/>
-          </ac:spMkLst>
-        </pc:spChg>
-        <pc:spChg chg="add mod">
-          <ac:chgData name="Fatima Pillosu" userId="a6295d4dc9e22643" providerId="LiveId" clId="{87453732-75AC-4426-B5D3-B7C69C2D4F54}" dt="2026-01-23T06:34:29.074" v="1464" actId="1076"/>
-          <ac:spMkLst>
-            <pc:docMk/>
-            <pc:sldMk cId="1573992039" sldId="256"/>
-            <ac:spMk id="1234" creationId="{DA721B03-BDAC-27CA-26E3-15F1149EDA51}"/>
-          </ac:spMkLst>
-        </pc:spChg>
-        <pc:spChg chg="add mod">
-          <ac:chgData name="Fatima Pillosu" userId="a6295d4dc9e22643" providerId="LiveId" clId="{87453732-75AC-4426-B5D3-B7C69C2D4F54}" dt="2026-01-23T06:34:29.074" v="1464" actId="1076"/>
-          <ac:spMkLst>
-            <pc:docMk/>
-            <pc:sldMk cId="1573992039" sldId="256"/>
-            <ac:spMk id="1235" creationId="{1AC770C5-B169-AD42-5A18-4A96F4AAC699}"/>
-          </ac:spMkLst>
-        </pc:spChg>
-        <pc:spChg chg="add mod">
-          <ac:chgData name="Fatima Pillosu" userId="a6295d4dc9e22643" providerId="LiveId" clId="{87453732-75AC-4426-B5D3-B7C69C2D4F54}" dt="2026-01-23T06:34:29.074" v="1464" actId="1076"/>
-          <ac:spMkLst>
-            <pc:docMk/>
-            <pc:sldMk cId="1573992039" sldId="256"/>
-            <ac:spMk id="1236" creationId="{205AA99D-99A0-911E-3713-D74FA9FAE1EF}"/>
-          </ac:spMkLst>
-        </pc:spChg>
-        <pc:spChg chg="add mod">
-          <ac:chgData name="Fatima Pillosu" userId="a6295d4dc9e22643" providerId="LiveId" clId="{87453732-75AC-4426-B5D3-B7C69C2D4F54}" dt="2026-01-23T06:34:29.074" v="1464" actId="1076"/>
-          <ac:spMkLst>
-            <pc:docMk/>
-            <pc:sldMk cId="1573992039" sldId="256"/>
-            <ac:spMk id="1238" creationId="{AEC17ABF-0E37-9F99-9544-E60745A0A06E}"/>
-          </ac:spMkLst>
-        </pc:spChg>
-        <pc:spChg chg="add mod">
-          <ac:chgData name="Fatima Pillosu" userId="a6295d4dc9e22643" providerId="LiveId" clId="{87453732-75AC-4426-B5D3-B7C69C2D4F54}" dt="2026-01-23T06:34:29.074" v="1464" actId="1076"/>
-          <ac:spMkLst>
-            <pc:docMk/>
-            <pc:sldMk cId="1573992039" sldId="256"/>
-            <ac:spMk id="1239" creationId="{59A1034C-3AC9-A33E-267C-705B6EAEEF8B}"/>
-          </ac:spMkLst>
-        </pc:spChg>
-        <pc:spChg chg="add mod">
-          <ac:chgData name="Fatima Pillosu" userId="a6295d4dc9e22643" providerId="LiveId" clId="{87453732-75AC-4426-B5D3-B7C69C2D4F54}" dt="2026-01-23T06:34:29.074" v="1464" actId="1076"/>
-          <ac:spMkLst>
-            <pc:docMk/>
-            <pc:sldMk cId="1573992039" sldId="256"/>
-            <ac:spMk id="1240" creationId="{B74D7124-C164-5658-DAC4-D088DCEDF376}"/>
-          </ac:spMkLst>
-        </pc:spChg>
-        <pc:spChg chg="mod">
-          <ac:chgData name="Fatima Pillosu" userId="a6295d4dc9e22643" providerId="LiveId" clId="{87453732-75AC-4426-B5D3-B7C69C2D4F54}" dt="2026-01-23T06:34:29.074" v="1464" actId="1076"/>
-          <ac:spMkLst>
-            <pc:docMk/>
-            <pc:sldMk cId="1573992039" sldId="256"/>
-            <ac:spMk id="1241" creationId="{958CFBDE-7C39-857A-E9EC-7E2FA5FEEF41}"/>
-          </ac:spMkLst>
-        </pc:spChg>
-        <pc:spChg chg="add mod">
-          <ac:chgData name="Fatima Pillosu" userId="a6295d4dc9e22643" providerId="LiveId" clId="{87453732-75AC-4426-B5D3-B7C69C2D4F54}" dt="2026-01-23T06:34:29.074" v="1464" actId="1076"/>
-          <ac:spMkLst>
-            <pc:docMk/>
-            <pc:sldMk cId="1573992039" sldId="256"/>
-            <ac:spMk id="1242" creationId="{BDACE84E-D727-0BBE-8B62-79323712A7F0}"/>
-          </ac:spMkLst>
-        </pc:spChg>
-        <pc:spChg chg="add del mod">
-          <ac:chgData name="Fatima Pillosu" userId="a6295d4dc9e22643" providerId="LiveId" clId="{87453732-75AC-4426-B5D3-B7C69C2D4F54}" dt="2026-01-23T06:32:49.190" v="1452" actId="478"/>
-          <ac:spMkLst>
-            <pc:docMk/>
-            <pc:sldMk cId="1573992039" sldId="256"/>
-            <ac:spMk id="1243" creationId="{FD301BCA-B1CD-2240-D141-63A86D3880BC}"/>
-          </ac:spMkLst>
-        </pc:spChg>
-        <pc:spChg chg="add del">
-          <ac:chgData name="Fatima Pillosu" userId="a6295d4dc9e22643" providerId="LiveId" clId="{87453732-75AC-4426-B5D3-B7C69C2D4F54}" dt="2026-01-23T06:35:03.946" v="1468" actId="478"/>
-          <ac:spMkLst>
-            <pc:docMk/>
-            <pc:sldMk cId="1573992039" sldId="256"/>
-            <ac:spMk id="1244" creationId="{17229520-D976-2AB8-9A14-9750AA3FAD64}"/>
-          </ac:spMkLst>
-        </pc:spChg>
         <pc:spChg chg="add mod">
           <ac:chgData name="Fatima Pillosu" userId="a6295d4dc9e22643" providerId="LiveId" clId="{87453732-75AC-4426-B5D3-B7C69C2D4F54}" dt="2026-01-23T06:35:33.051" v="1470"/>
           <ac:spMkLst>
@@ -1759,188 +215,20 @@
             <ac:spMk id="1364" creationId="{DA721B03-BDAC-27CA-26E3-15F1149EDA51}"/>
           </ac:spMkLst>
         </pc:spChg>
-        <pc:grpChg chg="add del mod">
-          <ac:chgData name="Fatima Pillosu" userId="a6295d4dc9e22643" providerId="LiveId" clId="{87453732-75AC-4426-B5D3-B7C69C2D4F54}" dt="2026-01-23T06:15:57.811" v="764" actId="165"/>
-          <ac:grpSpMkLst>
-            <pc:docMk/>
-            <pc:sldMk cId="1573992039" sldId="256"/>
-            <ac:grpSpMk id="37" creationId="{51868F4F-B026-A8A3-BA56-0783EBA64826}"/>
-          </ac:grpSpMkLst>
-        </pc:grpChg>
-        <pc:grpChg chg="del">
-          <ac:chgData name="Fatima Pillosu" userId="a6295d4dc9e22643" providerId="LiveId" clId="{87453732-75AC-4426-B5D3-B7C69C2D4F54}" dt="2026-01-23T06:07:37.998" v="315" actId="478"/>
-          <ac:grpSpMkLst>
-            <pc:docMk/>
-            <pc:sldMk cId="1573992039" sldId="256"/>
-            <ac:grpSpMk id="1078" creationId="{F05C852A-D7BE-F512-A142-B8804CE3138D}"/>
-          </ac:grpSpMkLst>
-        </pc:grpChg>
-        <pc:grpChg chg="del">
-          <ac:chgData name="Fatima Pillosu" userId="a6295d4dc9e22643" providerId="LiveId" clId="{87453732-75AC-4426-B5D3-B7C69C2D4F54}" dt="2026-01-23T06:07:37.998" v="315" actId="478"/>
-          <ac:grpSpMkLst>
-            <pc:docMk/>
-            <pc:sldMk cId="1573992039" sldId="256"/>
-            <ac:grpSpMk id="1171" creationId="{AA40A703-DE63-D472-F523-55A412DA0AA0}"/>
-          </ac:grpSpMkLst>
-        </pc:grpChg>
-        <pc:cxnChg chg="add mod">
-          <ac:chgData name="Fatima Pillosu" userId="a6295d4dc9e22643" providerId="LiveId" clId="{87453732-75AC-4426-B5D3-B7C69C2D4F54}" dt="2026-01-23T06:10:28.342" v="557"/>
+        <pc:cxnChg chg="del">
+          <ac:chgData name="Fatima Pillosu" userId="a6295d4dc9e22643" providerId="LiveId" clId="{87453732-75AC-4426-B5D3-B7C69C2D4F54}" dt="2026-01-26T16:16:25.010" v="1472" actId="478"/>
           <ac:cxnSpMkLst>
             <pc:docMk/>
             <pc:sldMk cId="1573992039" sldId="256"/>
-            <ac:cxnSpMk id="6" creationId="{E3360A9B-46E0-2546-79F0-3F3AB4966218}"/>
+            <ac:cxnSpMk id="1317" creationId="{D3BBCBB6-DF6B-BCC2-FC6C-434766CFCB16}"/>
           </ac:cxnSpMkLst>
         </pc:cxnChg>
-        <pc:cxnChg chg="add mod">
-          <ac:chgData name="Fatima Pillosu" userId="a6295d4dc9e22643" providerId="LiveId" clId="{87453732-75AC-4426-B5D3-B7C69C2D4F54}" dt="2026-01-23T06:10:39.073" v="560" actId="1076"/>
+        <pc:cxnChg chg="del">
+          <ac:chgData name="Fatima Pillosu" userId="a6295d4dc9e22643" providerId="LiveId" clId="{87453732-75AC-4426-B5D3-B7C69C2D4F54}" dt="2026-01-26T16:16:23.850" v="1471" actId="478"/>
           <ac:cxnSpMkLst>
             <pc:docMk/>
             <pc:sldMk cId="1573992039" sldId="256"/>
-            <ac:cxnSpMk id="8" creationId="{E988DF1C-F407-944B-76FA-47D55B12403B}"/>
-          </ac:cxnSpMkLst>
-        </pc:cxnChg>
-        <pc:cxnChg chg="add del mod">
-          <ac:chgData name="Fatima Pillosu" userId="a6295d4dc9e22643" providerId="LiveId" clId="{87453732-75AC-4426-B5D3-B7C69C2D4F54}" dt="2026-01-23T06:10:46.313" v="562" actId="478"/>
-          <ac:cxnSpMkLst>
-            <pc:docMk/>
-            <pc:sldMk cId="1573992039" sldId="256"/>
-            <ac:cxnSpMk id="10" creationId="{627D64DB-58C1-3A2A-F44C-F857B06ED362}"/>
-          </ac:cxnSpMkLst>
-        </pc:cxnChg>
-        <pc:cxnChg chg="add del mod ord">
-          <ac:chgData name="Fatima Pillosu" userId="a6295d4dc9e22643" providerId="LiveId" clId="{87453732-75AC-4426-B5D3-B7C69C2D4F54}" dt="2026-01-23T06:11:14.947" v="571" actId="167"/>
-          <ac:cxnSpMkLst>
-            <pc:docMk/>
-            <pc:sldMk cId="1573992039" sldId="256"/>
-            <ac:cxnSpMk id="11" creationId="{AF833556-3E86-7DDA-9647-16F5D993D16D}"/>
-          </ac:cxnSpMkLst>
-        </pc:cxnChg>
-        <pc:cxnChg chg="add mod">
-          <ac:chgData name="Fatima Pillosu" userId="a6295d4dc9e22643" providerId="LiveId" clId="{87453732-75AC-4426-B5D3-B7C69C2D4F54}" dt="2026-01-23T06:11:41.596" v="573" actId="571"/>
-          <ac:cxnSpMkLst>
-            <pc:docMk/>
-            <pc:sldMk cId="1573992039" sldId="256"/>
-            <ac:cxnSpMk id="13" creationId="{EAD3AABB-E83B-4F40-54E7-E2BB62ACAD90}"/>
-          </ac:cxnSpMkLst>
-        </pc:cxnChg>
-        <pc:cxnChg chg="add mod">
-          <ac:chgData name="Fatima Pillosu" userId="a6295d4dc9e22643" providerId="LiveId" clId="{87453732-75AC-4426-B5D3-B7C69C2D4F54}" dt="2026-01-23T06:11:41.596" v="573" actId="571"/>
-          <ac:cxnSpMkLst>
-            <pc:docMk/>
-            <pc:sldMk cId="1573992039" sldId="256"/>
-            <ac:cxnSpMk id="14" creationId="{9422DAA2-14EA-1C7A-B614-67BFC67FFD79}"/>
-          </ac:cxnSpMkLst>
-        </pc:cxnChg>
-        <pc:cxnChg chg="add del mod">
-          <ac:chgData name="Fatima Pillosu" userId="a6295d4dc9e22643" providerId="LiveId" clId="{87453732-75AC-4426-B5D3-B7C69C2D4F54}" dt="2026-01-23T06:12:11.085" v="579" actId="478"/>
-          <ac:cxnSpMkLst>
-            <pc:docMk/>
-            <pc:sldMk cId="1573992039" sldId="256"/>
-            <ac:cxnSpMk id="16" creationId="{4C2B11B8-BA62-6969-0942-79529914627D}"/>
-          </ac:cxnSpMkLst>
-        </pc:cxnChg>
-        <pc:cxnChg chg="add mod">
-          <ac:chgData name="Fatima Pillosu" userId="a6295d4dc9e22643" providerId="LiveId" clId="{87453732-75AC-4426-B5D3-B7C69C2D4F54}" dt="2026-01-23T06:16:04.064" v="772" actId="1037"/>
-          <ac:cxnSpMkLst>
-            <pc:docMk/>
-            <pc:sldMk cId="1573992039" sldId="256"/>
-            <ac:cxnSpMk id="17" creationId="{5C8C62E2-2461-F3C2-D9E0-4DC7238B1F80}"/>
-          </ac:cxnSpMkLst>
-        </pc:cxnChg>
-        <pc:cxnChg chg="add mod">
-          <ac:chgData name="Fatima Pillosu" userId="a6295d4dc9e22643" providerId="LiveId" clId="{87453732-75AC-4426-B5D3-B7C69C2D4F54}" dt="2026-01-23T06:16:04.064" v="772" actId="1037"/>
-          <ac:cxnSpMkLst>
-            <pc:docMk/>
-            <pc:sldMk cId="1573992039" sldId="256"/>
-            <ac:cxnSpMk id="18" creationId="{D3BBCBB6-DF6B-BCC2-FC6C-434766CFCB16}"/>
-          </ac:cxnSpMkLst>
-        </pc:cxnChg>
-        <pc:cxnChg chg="add del mod">
-          <ac:chgData name="Fatima Pillosu" userId="a6295d4dc9e22643" providerId="LiveId" clId="{87453732-75AC-4426-B5D3-B7C69C2D4F54}" dt="2026-01-23T06:12:10.124" v="578" actId="478"/>
-          <ac:cxnSpMkLst>
-            <pc:docMk/>
-            <pc:sldMk cId="1573992039" sldId="256"/>
-            <ac:cxnSpMk id="20" creationId="{34DAA4D4-090B-9CC9-9AB6-4D823775E218}"/>
-          </ac:cxnSpMkLst>
-        </pc:cxnChg>
-        <pc:cxnChg chg="add mod">
-          <ac:chgData name="Fatima Pillosu" userId="a6295d4dc9e22643" providerId="LiveId" clId="{87453732-75AC-4426-B5D3-B7C69C2D4F54}" dt="2026-01-23T06:15:49.151" v="763" actId="1037"/>
-          <ac:cxnSpMkLst>
-            <pc:docMk/>
-            <pc:sldMk cId="1573992039" sldId="256"/>
-            <ac:cxnSpMk id="22" creationId="{93E9F0D0-D74F-58F5-B76B-89F6B8312968}"/>
-          </ac:cxnSpMkLst>
-        </pc:cxnChg>
-        <pc:cxnChg chg="add mod">
-          <ac:chgData name="Fatima Pillosu" userId="a6295d4dc9e22643" providerId="LiveId" clId="{87453732-75AC-4426-B5D3-B7C69C2D4F54}" dt="2026-01-23T06:16:17.192" v="783" actId="1038"/>
-          <ac:cxnSpMkLst>
-            <pc:docMk/>
-            <pc:sldMk cId="1573992039" sldId="256"/>
-            <ac:cxnSpMk id="32" creationId="{BDDEB3EA-5566-17A1-8380-E298772FD972}"/>
-          </ac:cxnSpMkLst>
-        </pc:cxnChg>
-        <pc:cxnChg chg="mod">
-          <ac:chgData name="Fatima Pillosu" userId="a6295d4dc9e22643" providerId="LiveId" clId="{87453732-75AC-4426-B5D3-B7C69C2D4F54}" dt="2026-01-23T06:28:55.409" v="1328" actId="1037"/>
-          <ac:cxnSpMkLst>
-            <pc:docMk/>
-            <pc:sldMk cId="1573992039" sldId="256"/>
-            <ac:cxnSpMk id="862" creationId="{5C8C62E2-2461-F3C2-D9E0-4DC7238B1F80}"/>
-          </ac:cxnSpMkLst>
-        </pc:cxnChg>
-        <pc:cxnChg chg="mod">
-          <ac:chgData name="Fatima Pillosu" userId="a6295d4dc9e22643" providerId="LiveId" clId="{87453732-75AC-4426-B5D3-B7C69C2D4F54}" dt="2026-01-23T06:22:47.923" v="1078" actId="1076"/>
-          <ac:cxnSpMkLst>
-            <pc:docMk/>
-            <pc:sldMk cId="1573992039" sldId="256"/>
-            <ac:cxnSpMk id="863" creationId="{D3BBCBB6-DF6B-BCC2-FC6C-434766CFCB16}"/>
-          </ac:cxnSpMkLst>
-        </pc:cxnChg>
-        <pc:cxnChg chg="del">
-          <ac:chgData name="Fatima Pillosu" userId="a6295d4dc9e22643" providerId="LiveId" clId="{87453732-75AC-4426-B5D3-B7C69C2D4F54}" dt="2026-01-23T06:12:33.008" v="583" actId="478"/>
-          <ac:cxnSpMkLst>
-            <pc:docMk/>
-            <pc:sldMk cId="1573992039" sldId="256"/>
-            <ac:cxnSpMk id="1136" creationId="{FF1A36D5-26A9-D5BD-AA4F-6A758B0FDD22}"/>
-          </ac:cxnSpMkLst>
-        </pc:cxnChg>
-        <pc:cxnChg chg="del mod">
-          <ac:chgData name="Fatima Pillosu" userId="a6295d4dc9e22643" providerId="LiveId" clId="{87453732-75AC-4426-B5D3-B7C69C2D4F54}" dt="2026-01-23T06:12:31.512" v="582" actId="478"/>
-          <ac:cxnSpMkLst>
-            <pc:docMk/>
-            <pc:sldMk cId="1573992039" sldId="256"/>
-            <ac:cxnSpMk id="1138" creationId="{68B22122-705A-6D54-15DC-30E70B313128}"/>
-          </ac:cxnSpMkLst>
-        </pc:cxnChg>
-        <pc:cxnChg chg="del mod">
-          <ac:chgData name="Fatima Pillosu" userId="a6295d4dc9e22643" providerId="LiveId" clId="{87453732-75AC-4426-B5D3-B7C69C2D4F54}" dt="2026-01-23T06:11:08.795" v="570" actId="478"/>
-          <ac:cxnSpMkLst>
-            <pc:docMk/>
-            <pc:sldMk cId="1573992039" sldId="256"/>
-            <ac:cxnSpMk id="1139" creationId="{8C280FBD-2607-00B7-E97E-5D110246DB78}"/>
-          </ac:cxnSpMkLst>
-        </pc:cxnChg>
-        <pc:cxnChg chg="del mod">
-          <ac:chgData name="Fatima Pillosu" userId="a6295d4dc9e22643" providerId="LiveId" clId="{87453732-75AC-4426-B5D3-B7C69C2D4F54}" dt="2026-01-23T06:10:48.250" v="563" actId="478"/>
-          <ac:cxnSpMkLst>
-            <pc:docMk/>
-            <pc:sldMk cId="1573992039" sldId="256"/>
-            <ac:cxnSpMk id="1151" creationId="{DF0DFA06-B349-BFFF-59D7-AF6FCC570731}"/>
-          </ac:cxnSpMkLst>
-        </pc:cxnChg>
-        <pc:cxnChg chg="del">
-          <ac:chgData name="Fatima Pillosu" userId="a6295d4dc9e22643" providerId="LiveId" clId="{87453732-75AC-4426-B5D3-B7C69C2D4F54}" dt="2026-01-23T06:30:13.121" v="1363" actId="478"/>
-          <ac:cxnSpMkLst>
-            <pc:docMk/>
-            <pc:sldMk cId="1573992039" sldId="256"/>
-            <ac:cxnSpMk id="1225" creationId="{6377B571-F84C-847C-0578-68AA121A2CD9}"/>
-          </ac:cxnSpMkLst>
-        </pc:cxnChg>
-        <pc:cxnChg chg="del">
-          <ac:chgData name="Fatima Pillosu" userId="a6295d4dc9e22643" providerId="LiveId" clId="{87453732-75AC-4426-B5D3-B7C69C2D4F54}" dt="2026-01-23T06:30:13.121" v="1363" actId="478"/>
-          <ac:cxnSpMkLst>
-            <pc:docMk/>
-            <pc:sldMk cId="1573992039" sldId="256"/>
-            <ac:cxnSpMk id="1226" creationId="{4BA5C9E2-DD87-7967-84D7-84757553A588}"/>
+            <ac:cxnSpMk id="1327" creationId="{BDDEB3EA-5566-17A1-8380-E298772FD972}"/>
           </ac:cxnSpMkLst>
         </pc:cxnChg>
       </pc:sldChg>
@@ -2080,7 +368,7 @@
           <a:p>
             <a:fld id="{1B0A7230-9229-4B4E-8CC9-329D15B7627B}" type="datetimeFigureOut">
               <a:rPr lang="en-GB" smtClean="0"/>
-              <a:t>23/01/2026</a:t>
+              <a:t>26/01/2026</a:t>
             </a:fld>
             <a:endParaRPr lang="en-GB"/>
           </a:p>
@@ -2250,7 +538,7 @@
           <a:p>
             <a:fld id="{1B0A7230-9229-4B4E-8CC9-329D15B7627B}" type="datetimeFigureOut">
               <a:rPr lang="en-GB" smtClean="0"/>
-              <a:t>23/01/2026</a:t>
+              <a:t>26/01/2026</a:t>
             </a:fld>
             <a:endParaRPr lang="en-GB"/>
           </a:p>
@@ -2430,7 +718,7 @@
           <a:p>
             <a:fld id="{1B0A7230-9229-4B4E-8CC9-329D15B7627B}" type="datetimeFigureOut">
               <a:rPr lang="en-GB" smtClean="0"/>
-              <a:t>23/01/2026</a:t>
+              <a:t>26/01/2026</a:t>
             </a:fld>
             <a:endParaRPr lang="en-GB"/>
           </a:p>
@@ -2600,7 +888,7 @@
           <a:p>
             <a:fld id="{1B0A7230-9229-4B4E-8CC9-329D15B7627B}" type="datetimeFigureOut">
               <a:rPr lang="en-GB" smtClean="0"/>
-              <a:t>23/01/2026</a:t>
+              <a:t>26/01/2026</a:t>
             </a:fld>
             <a:endParaRPr lang="en-GB"/>
           </a:p>
@@ -2846,7 +1134,7 @@
           <a:p>
             <a:fld id="{1B0A7230-9229-4B4E-8CC9-329D15B7627B}" type="datetimeFigureOut">
               <a:rPr lang="en-GB" smtClean="0"/>
-              <a:t>23/01/2026</a:t>
+              <a:t>26/01/2026</a:t>
             </a:fld>
             <a:endParaRPr lang="en-GB"/>
           </a:p>
@@ -3078,7 +1366,7 @@
           <a:p>
             <a:fld id="{1B0A7230-9229-4B4E-8CC9-329D15B7627B}" type="datetimeFigureOut">
               <a:rPr lang="en-GB" smtClean="0"/>
-              <a:t>23/01/2026</a:t>
+              <a:t>26/01/2026</a:t>
             </a:fld>
             <a:endParaRPr lang="en-GB"/>
           </a:p>
@@ -3445,7 +1733,7 @@
           <a:p>
             <a:fld id="{1B0A7230-9229-4B4E-8CC9-329D15B7627B}" type="datetimeFigureOut">
               <a:rPr lang="en-GB" smtClean="0"/>
-              <a:t>23/01/2026</a:t>
+              <a:t>26/01/2026</a:t>
             </a:fld>
             <a:endParaRPr lang="en-GB"/>
           </a:p>
@@ -3563,7 +1851,7 @@
           <a:p>
             <a:fld id="{1B0A7230-9229-4B4E-8CC9-329D15B7627B}" type="datetimeFigureOut">
               <a:rPr lang="en-GB" smtClean="0"/>
-              <a:t>23/01/2026</a:t>
+              <a:t>26/01/2026</a:t>
             </a:fld>
             <a:endParaRPr lang="en-GB"/>
           </a:p>
@@ -3658,7 +1946,7 @@
           <a:p>
             <a:fld id="{1B0A7230-9229-4B4E-8CC9-329D15B7627B}" type="datetimeFigureOut">
               <a:rPr lang="en-GB" smtClean="0"/>
-              <a:t>23/01/2026</a:t>
+              <a:t>26/01/2026</a:t>
             </a:fld>
             <a:endParaRPr lang="en-GB"/>
           </a:p>
@@ -3935,7 +2223,7 @@
           <a:p>
             <a:fld id="{1B0A7230-9229-4B4E-8CC9-329D15B7627B}" type="datetimeFigureOut">
               <a:rPr lang="en-GB" smtClean="0"/>
-              <a:t>23/01/2026</a:t>
+              <a:t>26/01/2026</a:t>
             </a:fld>
             <a:endParaRPr lang="en-GB"/>
           </a:p>
@@ -4192,7 +2480,7 @@
           <a:p>
             <a:fld id="{1B0A7230-9229-4B4E-8CC9-329D15B7627B}" type="datetimeFigureOut">
               <a:rPr lang="en-GB" smtClean="0"/>
-              <a:t>23/01/2026</a:t>
+              <a:t>26/01/2026</a:t>
             </a:fld>
             <a:endParaRPr lang="en-GB"/>
           </a:p>
@@ -4405,7 +2693,7 @@
           <a:p>
             <a:fld id="{1B0A7230-9229-4B4E-8CC9-329D15B7627B}" type="datetimeFigureOut">
               <a:rPr lang="en-GB" smtClean="0"/>
-              <a:t>23/01/2026</a:t>
+              <a:t>26/01/2026</a:t>
             </a:fld>
             <a:endParaRPr lang="en-GB"/>
           </a:p>
@@ -8274,49 +6562,6 @@
       </p:cxnSp>
       <p:cxnSp>
         <p:nvCxnSpPr>
-          <p:cNvPr id="1317" name="Straight Connector 1316">
-            <a:extLst>
-              <a:ext uri="{FF2B5EF4-FFF2-40B4-BE49-F238E27FC236}">
-                <a16:creationId xmlns:a16="http://schemas.microsoft.com/office/drawing/2014/main" id="{D3BBCBB6-DF6B-BCC2-FC6C-434766CFCB16}"/>
-              </a:ext>
-            </a:extLst>
-          </p:cNvPr>
-          <p:cNvCxnSpPr>
-            <a:cxnSpLocks/>
-          </p:cNvCxnSpPr>
-          <p:nvPr/>
-        </p:nvCxnSpPr>
-        <p:spPr>
-          <a:xfrm flipH="1">
-            <a:off x="2544607" y="924577"/>
-            <a:ext cx="0" cy="537043"/>
-          </a:xfrm>
-          <a:prstGeom prst="line">
-            <a:avLst/>
-          </a:prstGeom>
-          <a:ln w="38100">
-            <a:solidFill>
-              <a:schemeClr val="tx1"/>
-            </a:solidFill>
-          </a:ln>
-        </p:spPr>
-        <p:style>
-          <a:lnRef idx="2">
-            <a:schemeClr val="accent1"/>
-          </a:lnRef>
-          <a:fillRef idx="0">
-            <a:schemeClr val="accent1"/>
-          </a:fillRef>
-          <a:effectRef idx="1">
-            <a:schemeClr val="accent1"/>
-          </a:effectRef>
-          <a:fontRef idx="minor">
-            <a:schemeClr val="tx1"/>
-          </a:fontRef>
-        </p:style>
-      </p:cxnSp>
-      <p:cxnSp>
-        <p:nvCxnSpPr>
           <p:cNvPr id="1318" name="Straight Connector 1317">
             <a:extLst>
               <a:ext uri="{FF2B5EF4-FFF2-40B4-BE49-F238E27FC236}">
@@ -8689,49 +6934,6 @@
           </a:p>
         </p:txBody>
       </p:sp>
-      <p:cxnSp>
-        <p:nvCxnSpPr>
-          <p:cNvPr id="1327" name="Straight Connector 1326">
-            <a:extLst>
-              <a:ext uri="{FF2B5EF4-FFF2-40B4-BE49-F238E27FC236}">
-                <a16:creationId xmlns:a16="http://schemas.microsoft.com/office/drawing/2014/main" id="{BDDEB3EA-5566-17A1-8380-E298772FD972}"/>
-              </a:ext>
-            </a:extLst>
-          </p:cNvPr>
-          <p:cNvCxnSpPr>
-            <a:cxnSpLocks/>
-          </p:cNvCxnSpPr>
-          <p:nvPr/>
-        </p:nvCxnSpPr>
-        <p:spPr>
-          <a:xfrm>
-            <a:off x="1248072" y="922354"/>
-            <a:ext cx="541791" cy="0"/>
-          </a:xfrm>
-          <a:prstGeom prst="line">
-            <a:avLst/>
-          </a:prstGeom>
-          <a:ln w="38100">
-            <a:solidFill>
-              <a:schemeClr val="tx1"/>
-            </a:solidFill>
-          </a:ln>
-        </p:spPr>
-        <p:style>
-          <a:lnRef idx="2">
-            <a:schemeClr val="accent1"/>
-          </a:lnRef>
-          <a:fillRef idx="0">
-            <a:schemeClr val="accent1"/>
-          </a:fillRef>
-          <a:effectRef idx="1">
-            <a:schemeClr val="accent1"/>
-          </a:effectRef>
-          <a:fontRef idx="minor">
-            <a:schemeClr val="tx1"/>
-          </a:fontRef>
-        </p:style>
-      </p:cxnSp>
       <p:cxnSp>
         <p:nvCxnSpPr>
           <p:cNvPr id="1328" name="Straight Connector 1327">

</xml_diff>

<commit_message>
Improved forecasts in chapter 5
</commit_message>
<xml_diff>
--- a/chapter_05/figures/break_down_scores.pptx
+++ b/chapter_05/figures/break_down_scores.pptx
@@ -115,7 +115,7 @@
 <file path=ppt/revisionInfo.xml><?xml version="1.0" encoding="utf-8"?>
 <p1510:revInfo xmlns:a="http://schemas.openxmlformats.org/drawingml/2006/main" xmlns:r="http://schemas.openxmlformats.org/officeDocument/2006/relationships" xmlns:p1510="http://schemas.microsoft.com/office/powerpoint/2015/10/main">
   <p1510:revLst>
-    <p1510:client id="{4461CCDA-CA71-4734-AE8B-A76D60A46F58}" v="112" dt="2026-01-23T06:35:33.051"/>
+    <p1510:client id="{4461CCDA-CA71-4734-AE8B-A76D60A46F58}" v="116" dt="2026-01-26T21:18:12.337"/>
   </p1510:revLst>
 </p1510:revInfo>
 </file>
@@ -125,16 +125,32 @@
   <pc:docChgLst>
     <pc:chgData name="Fatima Pillosu" userId="a6295d4dc9e22643" providerId="LiveId" clId="{87453732-75AC-4426-B5D3-B7C69C2D4F54}"/>
     <pc:docChg chg="undo custSel modSld">
-      <pc:chgData name="Fatima Pillosu" userId="a6295d4dc9e22643" providerId="LiveId" clId="{87453732-75AC-4426-B5D3-B7C69C2D4F54}" dt="2026-01-26T16:16:25.010" v="1472" actId="478"/>
+      <pc:chgData name="Fatima Pillosu" userId="a6295d4dc9e22643" providerId="LiveId" clId="{87453732-75AC-4426-B5D3-B7C69C2D4F54}" dt="2026-01-26T21:18:15.211" v="1523" actId="1076"/>
       <pc:docMkLst>
         <pc:docMk/>
       </pc:docMkLst>
       <pc:sldChg chg="addSp delSp modSp mod">
-        <pc:chgData name="Fatima Pillosu" userId="a6295d4dc9e22643" providerId="LiveId" clId="{87453732-75AC-4426-B5D3-B7C69C2D4F54}" dt="2026-01-26T16:16:25.010" v="1472" actId="478"/>
+        <pc:chgData name="Fatima Pillosu" userId="a6295d4dc9e22643" providerId="LiveId" clId="{87453732-75AC-4426-B5D3-B7C69C2D4F54}" dt="2026-01-26T21:18:15.211" v="1523" actId="1076"/>
         <pc:sldMkLst>
           <pc:docMk/>
           <pc:sldMk cId="1573992039" sldId="256"/>
         </pc:sldMkLst>
+        <pc:spChg chg="add mod">
+          <ac:chgData name="Fatima Pillosu" userId="a6295d4dc9e22643" providerId="LiveId" clId="{87453732-75AC-4426-B5D3-B7C69C2D4F54}" dt="2026-01-26T21:17:40.833" v="1516" actId="20577"/>
+          <ac:spMkLst>
+            <pc:docMk/>
+            <pc:sldMk cId="1573992039" sldId="256"/>
+            <ac:spMk id="11" creationId="{29C18B43-AD11-4F29-1F26-2B3A6B1115CB}"/>
+          </ac:spMkLst>
+        </pc:spChg>
+        <pc:spChg chg="add mod">
+          <ac:chgData name="Fatima Pillosu" userId="a6295d4dc9e22643" providerId="LiveId" clId="{87453732-75AC-4426-B5D3-B7C69C2D4F54}" dt="2026-01-26T21:18:15.211" v="1523" actId="1076"/>
+          <ac:spMkLst>
+            <pc:docMk/>
+            <pc:sldMk cId="1573992039" sldId="256"/>
+            <ac:spMk id="13" creationId="{03B89C1A-7763-D500-8ADD-8052421B2211}"/>
+          </ac:spMkLst>
+        </pc:spChg>
         <pc:spChg chg="add mod">
           <ac:chgData name="Fatima Pillosu" userId="a6295d4dc9e22643" providerId="LiveId" clId="{87453732-75AC-4426-B5D3-B7C69C2D4F54}" dt="2026-01-23T06:35:33.051" v="1470"/>
           <ac:spMkLst>
@@ -183,8 +199,16 @@
             <ac:spMk id="1325" creationId="{127CFB41-2894-69E3-E62C-3DA0B561D707}"/>
           </ac:spMkLst>
         </pc:spChg>
+        <pc:spChg chg="mod">
+          <ac:chgData name="Fatima Pillosu" userId="a6295d4dc9e22643" providerId="LiveId" clId="{87453732-75AC-4426-B5D3-B7C69C2D4F54}" dt="2026-01-26T21:16:22.435" v="1487" actId="20577"/>
+          <ac:spMkLst>
+            <pc:docMk/>
+            <pc:sldMk cId="1573992039" sldId="256"/>
+            <ac:spMk id="1331" creationId="{5B4F7B26-B4B5-0D40-3F80-6AA916B5DA57}"/>
+          </ac:spMkLst>
+        </pc:spChg>
         <pc:spChg chg="add mod">
-          <ac:chgData name="Fatima Pillosu" userId="a6295d4dc9e22643" providerId="LiveId" clId="{87453732-75AC-4426-B5D3-B7C69C2D4F54}" dt="2026-01-23T06:35:33.051" v="1470"/>
+          <ac:chgData name="Fatima Pillosu" userId="a6295d4dc9e22643" providerId="LiveId" clId="{87453732-75AC-4426-B5D3-B7C69C2D4F54}" dt="2026-01-26T21:16:27.902" v="1496" actId="20577"/>
           <ac:spMkLst>
             <pc:docMk/>
             <pc:sldMk cId="1573992039" sldId="256"/>
@@ -215,6 +239,38 @@
             <ac:spMk id="1364" creationId="{DA721B03-BDAC-27CA-26E3-15F1149EDA51}"/>
           </ac:spMkLst>
         </pc:spChg>
+        <pc:cxnChg chg="add del mod">
+          <ac:chgData name="Fatima Pillosu" userId="a6295d4dc9e22643" providerId="LiveId" clId="{87453732-75AC-4426-B5D3-B7C69C2D4F54}" dt="2026-01-26T21:16:40.013" v="1499" actId="478"/>
+          <ac:cxnSpMkLst>
+            <pc:docMk/>
+            <pc:sldMk cId="1573992039" sldId="256"/>
+            <ac:cxnSpMk id="2" creationId="{0014F949-7ADF-0582-9DD2-6E52406F9347}"/>
+          </ac:cxnSpMkLst>
+        </pc:cxnChg>
+        <pc:cxnChg chg="add mod">
+          <ac:chgData name="Fatima Pillosu" userId="a6295d4dc9e22643" providerId="LiveId" clId="{87453732-75AC-4426-B5D3-B7C69C2D4F54}" dt="2026-01-26T21:17:26.761" v="1508" actId="692"/>
+          <ac:cxnSpMkLst>
+            <pc:docMk/>
+            <pc:sldMk cId="1573992039" sldId="256"/>
+            <ac:cxnSpMk id="10" creationId="{E8D787D3-2BC9-5BBF-B9E5-8B9E3A1F1A37}"/>
+          </ac:cxnSpMkLst>
+        </pc:cxnChg>
+        <pc:cxnChg chg="add mod">
+          <ac:chgData name="Fatima Pillosu" userId="a6295d4dc9e22643" providerId="LiveId" clId="{87453732-75AC-4426-B5D3-B7C69C2D4F54}" dt="2026-01-26T21:18:10.091" v="1521" actId="1076"/>
+          <ac:cxnSpMkLst>
+            <pc:docMk/>
+            <pc:sldMk cId="1573992039" sldId="256"/>
+            <ac:cxnSpMk id="12" creationId="{576FCE02-F4E4-6B8F-E253-72C41A2EFEF5}"/>
+          </ac:cxnSpMkLst>
+        </pc:cxnChg>
+        <pc:cxnChg chg="mod">
+          <ac:chgData name="Fatima Pillosu" userId="a6295d4dc9e22643" providerId="LiveId" clId="{87453732-75AC-4426-B5D3-B7C69C2D4F54}" dt="2026-01-26T21:16:51.669" v="1502" actId="14100"/>
+          <ac:cxnSpMkLst>
+            <pc:docMk/>
+            <pc:sldMk cId="1573992039" sldId="256"/>
+            <ac:cxnSpMk id="1316" creationId="{5C8C62E2-2461-F3C2-D9E0-4DC7238B1F80}"/>
+          </ac:cxnSpMkLst>
+        </pc:cxnChg>
         <pc:cxnChg chg="del">
           <ac:chgData name="Fatima Pillosu" userId="a6295d4dc9e22643" providerId="LiveId" clId="{87453732-75AC-4426-B5D3-B7C69C2D4F54}" dt="2026-01-26T16:16:25.010" v="1472" actId="478"/>
           <ac:cxnSpMkLst>
@@ -229,6 +285,14 @@
             <pc:docMk/>
             <pc:sldMk cId="1573992039" sldId="256"/>
             <ac:cxnSpMk id="1327" creationId="{BDDEB3EA-5566-17A1-8380-E298772FD972}"/>
+          </ac:cxnSpMkLst>
+        </pc:cxnChg>
+        <pc:cxnChg chg="mod">
+          <ac:chgData name="Fatima Pillosu" userId="a6295d4dc9e22643" providerId="LiveId" clId="{87453732-75AC-4426-B5D3-B7C69C2D4F54}" dt="2026-01-26T21:17:03.453" v="1504" actId="1076"/>
+          <ac:cxnSpMkLst>
+            <pc:docMk/>
+            <pc:sldMk cId="1573992039" sldId="256"/>
+            <ac:cxnSpMk id="1328" creationId="{DA3DABA7-74E0-EDE3-5AB1-D084FE5BF3CC}"/>
           </ac:cxnSpMkLst>
         </pc:cxnChg>
       </pc:sldChg>
@@ -6532,9 +6596,9 @@
           <p:nvPr/>
         </p:nvCxnSpPr>
         <p:spPr>
-          <a:xfrm>
-            <a:off x="2010224" y="1472765"/>
-            <a:ext cx="541791" cy="0"/>
+          <a:xfrm flipV="1">
+            <a:off x="2002816" y="1367287"/>
+            <a:ext cx="495145" cy="65221"/>
           </a:xfrm>
           <a:prstGeom prst="line">
             <a:avLst/>
@@ -6950,8 +7014,8 @@
         </p:nvCxnSpPr>
         <p:spPr>
           <a:xfrm flipH="1">
-            <a:off x="1264634" y="911276"/>
-            <a:ext cx="0" cy="537043"/>
+            <a:off x="1252921" y="982367"/>
+            <a:ext cx="64120" cy="468000"/>
           </a:xfrm>
           <a:prstGeom prst="line">
             <a:avLst/>
@@ -7097,7 +7161,7 @@
                 <a:ea typeface="Calibri Light" panose="020F0302020204030204" pitchFamily="34" charset="0"/>
                 <a:cs typeface="Calibri Light" panose="020F0302020204030204" pitchFamily="34" charset="0"/>
               </a:rPr>
-              <a:t>Over-prediction</a:t>
+              <a:t>Under-prediction</a:t>
             </a:r>
           </a:p>
         </p:txBody>
@@ -7137,7 +7201,7 @@
                 <a:ea typeface="Calibri Light" panose="020F0302020204030204" pitchFamily="34" charset="0"/>
                 <a:cs typeface="Calibri Light" panose="020F0302020204030204" pitchFamily="34" charset="0"/>
               </a:rPr>
-              <a:t>Under-prediction</a:t>
+              <a:t>Over-prediction</a:t>
             </a:r>
           </a:p>
         </p:txBody>
@@ -10345,6 +10409,178 @@
           </a:p>
         </p:txBody>
       </p:sp>
+      <p:cxnSp>
+        <p:nvCxnSpPr>
+          <p:cNvPr id="10" name="Straight Arrow Connector 9">
+            <a:extLst>
+              <a:ext uri="{FF2B5EF4-FFF2-40B4-BE49-F238E27FC236}">
+                <a16:creationId xmlns:a16="http://schemas.microsoft.com/office/drawing/2014/main" id="{E8D787D3-2BC9-5BBF-B9E5-8B9E3A1F1A37}"/>
+              </a:ext>
+            </a:extLst>
+          </p:cNvPr>
+          <p:cNvCxnSpPr/>
+          <p:nvPr/>
+        </p:nvCxnSpPr>
+        <p:spPr>
+          <a:xfrm flipH="1" flipV="1">
+            <a:off x="1421359" y="987725"/>
+            <a:ext cx="132930" cy="82513"/>
+          </a:xfrm>
+          <a:prstGeom prst="straightConnector1">
+            <a:avLst/>
+          </a:prstGeom>
+          <a:ln w="3175">
+            <a:solidFill>
+              <a:schemeClr val="tx1">
+                <a:lumMod val="65000"/>
+                <a:lumOff val="35000"/>
+              </a:schemeClr>
+            </a:solidFill>
+            <a:tailEnd type="triangle" w="sm" len="sm"/>
+          </a:ln>
+        </p:spPr>
+        <p:style>
+          <a:lnRef idx="2">
+            <a:schemeClr val="accent1"/>
+          </a:lnRef>
+          <a:fillRef idx="0">
+            <a:schemeClr val="accent1"/>
+          </a:fillRef>
+          <a:effectRef idx="1">
+            <a:schemeClr val="accent1"/>
+          </a:effectRef>
+          <a:fontRef idx="minor">
+            <a:schemeClr val="tx1"/>
+          </a:fontRef>
+        </p:style>
+      </p:cxnSp>
+      <p:sp>
+        <p:nvSpPr>
+          <p:cNvPr id="11" name="TextBox 10">
+            <a:extLst>
+              <a:ext uri="{FF2B5EF4-FFF2-40B4-BE49-F238E27FC236}">
+                <a16:creationId xmlns:a16="http://schemas.microsoft.com/office/drawing/2014/main" id="{29C18B43-AD11-4F29-1F26-2B3A6B1115CB}"/>
+              </a:ext>
+            </a:extLst>
+          </p:cNvPr>
+          <p:cNvSpPr txBox="1"/>
+          <p:nvPr/>
+        </p:nvSpPr>
+        <p:spPr>
+          <a:xfrm>
+            <a:off x="1227459" y="1030802"/>
+            <a:ext cx="650910" cy="215444"/>
+          </a:xfrm>
+          <a:prstGeom prst="rect">
+            <a:avLst/>
+          </a:prstGeom>
+          <a:noFill/>
+        </p:spPr>
+        <p:txBody>
+          <a:bodyPr wrap="square" rtlCol="0">
+            <a:spAutoFit/>
+          </a:bodyPr>
+          <a:lstStyle/>
+          <a:p>
+            <a:pPr algn="ctr"/>
+            <a:r>
+              <a:rPr lang="en-US" sz="800" dirty="0">
+                <a:latin typeface="Calibri Light" panose="020F0302020204030204" pitchFamily="34" charset="0"/>
+                <a:ea typeface="Calibri Light" panose="020F0302020204030204" pitchFamily="34" charset="0"/>
+                <a:cs typeface="Calibri Light" panose="020F0302020204030204" pitchFamily="34" charset="0"/>
+              </a:rPr>
+              <a:t>Worse</a:t>
+            </a:r>
+          </a:p>
+        </p:txBody>
+      </p:sp>
+      <p:cxnSp>
+        <p:nvCxnSpPr>
+          <p:cNvPr id="12" name="Straight Arrow Connector 11">
+            <a:extLst>
+              <a:ext uri="{FF2B5EF4-FFF2-40B4-BE49-F238E27FC236}">
+                <a16:creationId xmlns:a16="http://schemas.microsoft.com/office/drawing/2014/main" id="{576FCE02-F4E4-6B8F-E253-72C41A2EFEF5}"/>
+              </a:ext>
+            </a:extLst>
+          </p:cNvPr>
+          <p:cNvCxnSpPr>
+            <a:cxnSpLocks/>
+          </p:cNvCxnSpPr>
+          <p:nvPr/>
+        </p:nvCxnSpPr>
+        <p:spPr>
+          <a:xfrm rot="10800000" flipH="1" flipV="1">
+            <a:off x="2369995" y="1151893"/>
+            <a:ext cx="132930" cy="82513"/>
+          </a:xfrm>
+          <a:prstGeom prst="straightConnector1">
+            <a:avLst/>
+          </a:prstGeom>
+          <a:ln w="3175">
+            <a:solidFill>
+              <a:schemeClr val="tx1">
+                <a:lumMod val="65000"/>
+                <a:lumOff val="35000"/>
+              </a:schemeClr>
+            </a:solidFill>
+            <a:tailEnd type="triangle" w="sm" len="sm"/>
+          </a:ln>
+        </p:spPr>
+        <p:style>
+          <a:lnRef idx="2">
+            <a:schemeClr val="accent1"/>
+          </a:lnRef>
+          <a:fillRef idx="0">
+            <a:schemeClr val="accent1"/>
+          </a:fillRef>
+          <a:effectRef idx="1">
+            <a:schemeClr val="accent1"/>
+          </a:effectRef>
+          <a:fontRef idx="minor">
+            <a:schemeClr val="tx1"/>
+          </a:fontRef>
+        </p:style>
+      </p:cxnSp>
+      <p:sp>
+        <p:nvSpPr>
+          <p:cNvPr id="13" name="TextBox 12">
+            <a:extLst>
+              <a:ext uri="{FF2B5EF4-FFF2-40B4-BE49-F238E27FC236}">
+                <a16:creationId xmlns:a16="http://schemas.microsoft.com/office/drawing/2014/main" id="{03B89C1A-7763-D500-8ADD-8052421B2211}"/>
+              </a:ext>
+            </a:extLst>
+          </p:cNvPr>
+          <p:cNvSpPr txBox="1"/>
+          <p:nvPr/>
+        </p:nvSpPr>
+        <p:spPr>
+          <a:xfrm>
+            <a:off x="1962826" y="1143200"/>
+            <a:ext cx="650910" cy="215444"/>
+          </a:xfrm>
+          <a:prstGeom prst="rect">
+            <a:avLst/>
+          </a:prstGeom>
+          <a:noFill/>
+        </p:spPr>
+        <p:txBody>
+          <a:bodyPr wrap="square" rtlCol="0">
+            <a:spAutoFit/>
+          </a:bodyPr>
+          <a:lstStyle/>
+          <a:p>
+            <a:pPr algn="ctr"/>
+            <a:r>
+              <a:rPr lang="en-US" sz="800" dirty="0">
+                <a:latin typeface="Calibri Light" panose="020F0302020204030204" pitchFamily="34" charset="0"/>
+                <a:ea typeface="Calibri Light" panose="020F0302020204030204" pitchFamily="34" charset="0"/>
+                <a:cs typeface="Calibri Light" panose="020F0302020204030204" pitchFamily="34" charset="0"/>
+              </a:rPr>
+              <a:t>Worse</a:t>
+            </a:r>
+          </a:p>
+        </p:txBody>
+      </p:sp>
     </p:spTree>
     <p:extLst>
       <p:ext uri="{BB962C8B-B14F-4D97-AF65-F5344CB8AC3E}">

</xml_diff>